<commit_message>
fix(fusion-v3): finalize evidence-safe submission deck
</commit_message>
<xml_diff>
--- a/competition/2026-08-15/alternatives/fusion-v3/agentfit-fusion-v3.pptx
+++ b/competition/2026-08-15/alternatives/fusion-v3/agentfit-fusion-v3.pptx
@@ -3889,7 +3889,7 @@
                 </a:solidFill>
                 <a:latin typeface="Noto Sans Mono CJK SC"/>
               </a:rPr>
-              <a:t>C2 · N Agents</a:t>
+              <a:t>C2 · N 业务 Agent</a:t>
             </a:r>
           </a:p>
         </p:txBody>
@@ -9239,11 +9239,11 @@
         <p:spPr>
           <a:xfrm>
             <a:off x="6172200" y="1962302"/>
-            <a:ext cx="5333695" cy="1123797"/>
+            <a:ext cx="5333695" cy="2686507"/>
           </a:xfrm>
           <a:prstGeom prst="roundRect">
             <a:avLst>
-              <a:gd name="adj" fmla="val 15250"/>
+              <a:gd name="adj" fmla="val 6380"/>
             </a:avLst>
           </a:prstGeom>
           <a:solidFill>
@@ -9333,33 +9333,33 @@
         <p:spPr>
           <a:xfrm>
             <a:off x="6400800" y="2361895"/>
-            <a:ext cx="4955133" cy="291693"/>
-          </a:xfrm>
-          <a:prstGeom prst="rect">
-            <a:avLst/>
-          </a:prstGeom>
-          <a:noFill/>
-        </p:spPr>
-        <p:txBody>
-          <a:bodyPr wrap="square" lIns="0" tIns="0" rIns="0" bIns="0">
-            <a:spAutoFit/>
-          </a:bodyPr>
-          <a:lstStyle/>
-          <a:p>
-            <a:pPr marL="0" indent="0" algn="l">
-              <a:lnSpc>
-                <a:spcPts val="2300"/>
-              </a:lnSpc>
-              <a:spcBef>
-                <a:spcPts val="0"/>
-              </a:spcBef>
-              <a:spcAft>
-                <a:spcPts val="0"/>
-              </a:spcAft>
-              <a:buNone/>
-            </a:pPr>
-            <a:r>
-              <a:rPr b="1" sz="1950">
+            <a:ext cx="4955133" cy="246888"/>
+          </a:xfrm>
+          <a:prstGeom prst="rect">
+            <a:avLst/>
+          </a:prstGeom>
+          <a:noFill/>
+        </p:spPr>
+        <p:txBody>
+          <a:bodyPr wrap="square" lIns="0" tIns="0" rIns="0" bIns="0">
+            <a:spAutoFit/>
+          </a:bodyPr>
+          <a:lstStyle/>
+          <a:p>
+            <a:pPr marL="0" indent="0" algn="l">
+              <a:lnSpc>
+                <a:spcPts val="1950"/>
+              </a:lnSpc>
+              <a:spcBef>
+                <a:spcPts val="0"/>
+              </a:spcBef>
+              <a:spcAft>
+                <a:spcPts val="0"/>
+              </a:spcAft>
+              <a:buNone/>
+            </a:pPr>
+            <a:r>
+              <a:rPr b="1" sz="1650">
                 <a:solidFill>
                   <a:srgbClr val="102A43"/>
                 </a:solidFill>
@@ -9378,7 +9378,7 @@
         </p:nvSpPr>
         <p:spPr>
           <a:xfrm>
-            <a:off x="6400800" y="2743200"/>
+            <a:off x="6400800" y="2667304"/>
             <a:ext cx="4955133" cy="172821"/>
           </a:xfrm>
           <a:prstGeom prst="rect">
@@ -9405,31 +9405,1194 @@
               <a:buNone/>
             </a:pPr>
             <a:r>
-              <a:rPr sz="980">
+              <a:rPr sz="1050">
                 <a:solidFill>
                   <a:srgbClr val="53697C"/>
                 </a:solidFill>
                 <a:latin typeface="Noto Sans CJK SC"/>
               </a:rPr>
-              <a:t>G 能力图 · Π Agent 分区 · θ 模型/Prompt/阈值 · ρ 状态与记忆共享范围</a:t>
-            </a:r>
-          </a:p>
-        </p:txBody>
-      </p:sp>
-      <p:sp>
-        <p:nvSpPr>
-          <p:cNvPr id="21" name="h2p-13-box-20"/>
+              <a:t>G 能力图 · Π Agent 分区 · θ 局部参数 · ρ 跨分区共享范围</a:t>
+            </a:r>
+          </a:p>
+        </p:txBody>
+      </p:sp>
+      <p:sp>
+        <p:nvSpPr>
+          <p:cNvPr id="21" name="h2p-13-text-20"/>
+          <p:cNvSpPr txBox="1"/>
+          <p:nvPr/>
+        </p:nvSpPr>
+        <p:spPr>
+          <a:xfrm>
+            <a:off x="6400800" y="2933395"/>
+            <a:ext cx="4955133" cy="168249"/>
+          </a:xfrm>
+          <a:prstGeom prst="rect">
+            <a:avLst/>
+          </a:prstGeom>
+          <a:noFill/>
+        </p:spPr>
+        <p:txBody>
+          <a:bodyPr wrap="square" lIns="0" tIns="0" rIns="0" bIns="0">
+            <a:spAutoFit/>
+          </a:bodyPr>
+          <a:lstStyle/>
+          <a:p>
+            <a:pPr marL="0" indent="0" algn="l">
+              <a:lnSpc>
+                <a:spcPts val="1320"/>
+              </a:lnSpc>
+              <a:spcBef>
+                <a:spcPts val="0"/>
+              </a:spcBef>
+              <a:spcAft>
+                <a:spcPts val="0"/>
+              </a:spcAft>
+              <a:buNone/>
+            </a:pPr>
+            <a:r>
+              <a:rPr b="1" sz="1050">
+                <a:solidFill>
+                  <a:srgbClr val="1A8D85"/>
+                </a:solidFill>
+                <a:latin typeface="Noto Sans CJK SC"/>
+              </a:rPr>
+              <a:t>G · DAG 主干 + Π 分区中的有界 SCC</a:t>
+            </a:r>
+          </a:p>
+        </p:txBody>
+      </p:sp>
+      <p:sp>
+        <p:nvSpPr>
+          <p:cNvPr id="22" name="h2p-13-box-21"/>
           <p:cNvSpPr/>
           <p:nvPr/>
         </p:nvSpPr>
         <p:spPr>
           <a:xfrm>
-            <a:off x="6172200" y="3219602"/>
-            <a:ext cx="2571292" cy="1981504"/>
+            <a:off x="6400800" y="3333902"/>
+            <a:ext cx="590702" cy="267004"/>
           </a:xfrm>
           <a:prstGeom prst="roundRect">
             <a:avLst>
-              <a:gd name="adj" fmla="val 8650"/>
+              <a:gd name="adj" fmla="val 50000"/>
+            </a:avLst>
+          </a:prstGeom>
+          <a:solidFill>
+            <a:srgbClr val="FFFFFF"/>
+          </a:solidFill>
+          <a:ln w="10160">
+            <a:solidFill>
+              <a:srgbClr val="426B86"/>
+            </a:solidFill>
+          </a:ln>
+          <a:effectLst/>
+        </p:spPr>
+        <p:style>
+          <a:lnRef idx="1">
+            <a:schemeClr val="accent1"/>
+          </a:lnRef>
+          <a:fillRef idx="3">
+            <a:schemeClr val="accent1"/>
+          </a:fillRef>
+          <a:effectRef idx="0">
+            <a:schemeClr val="accent1"/>
+          </a:effectRef>
+          <a:fontRef idx="minor">
+            <a:schemeClr val="lt1"/>
+          </a:fontRef>
+        </p:style>
+        <p:txBody>
+          <a:bodyPr rtlCol="0" anchor="ctr"/>
+          <a:lstStyle/>
+          <a:p>
+            <a:pPr algn="ctr"/>
+          </a:p>
+        </p:txBody>
+      </p:sp>
+      <p:sp>
+        <p:nvSpPr>
+          <p:cNvPr id="23" name="h2p-13-text-22"/>
+          <p:cNvSpPr txBox="1"/>
+          <p:nvPr/>
+        </p:nvSpPr>
+        <p:spPr>
+          <a:xfrm>
+            <a:off x="6404457" y="3372307"/>
+            <a:ext cx="583387" cy="228600"/>
+          </a:xfrm>
+          <a:prstGeom prst="rect">
+            <a:avLst/>
+          </a:prstGeom>
+          <a:noFill/>
+        </p:spPr>
+        <p:txBody>
+          <a:bodyPr wrap="square" lIns="0" tIns="0" rIns="0" bIns="0">
+            <a:spAutoFit/>
+          </a:bodyPr>
+          <a:lstStyle/>
+          <a:p>
+            <a:pPr marL="0" indent="0" algn="ctr">
+              <a:lnSpc>
+                <a:spcPts val="1440"/>
+              </a:lnSpc>
+              <a:spcBef>
+                <a:spcPts val="0"/>
+              </a:spcBef>
+              <a:spcAft>
+                <a:spcPts val="0"/>
+              </a:spcAft>
+              <a:buNone/>
+            </a:pPr>
+            <a:r>
+              <a:rPr sz="1200">
+                <a:solidFill>
+                  <a:srgbClr val="426B86"/>
+                </a:solidFill>
+                <a:latin typeface="Noto Sans CJK SC"/>
+              </a:rPr>
+              <a:t>去重</a:t>
+            </a:r>
+          </a:p>
+        </p:txBody>
+      </p:sp>
+      <p:sp>
+        <p:nvSpPr>
+          <p:cNvPr id="24" name="h2p-13-text-23"/>
+          <p:cNvSpPr txBox="1"/>
+          <p:nvPr/>
+        </p:nvSpPr>
+        <p:spPr>
+          <a:xfrm>
+            <a:off x="7029907" y="3353104"/>
+            <a:ext cx="155448" cy="228600"/>
+          </a:xfrm>
+          <a:prstGeom prst="rect">
+            <a:avLst/>
+          </a:prstGeom>
+          <a:noFill/>
+        </p:spPr>
+        <p:txBody>
+          <a:bodyPr wrap="square" lIns="0" tIns="0" rIns="0" bIns="0">
+            <a:spAutoFit/>
+          </a:bodyPr>
+          <a:lstStyle/>
+          <a:p>
+            <a:pPr marL="0" indent="0" algn="l">
+              <a:lnSpc>
+                <a:spcPts val="1440"/>
+              </a:lnSpc>
+              <a:spcBef>
+                <a:spcPts val="0"/>
+              </a:spcBef>
+              <a:spcAft>
+                <a:spcPts val="0"/>
+              </a:spcAft>
+              <a:buNone/>
+            </a:pPr>
+            <a:r>
+              <a:rPr sz="1200">
+                <a:solidFill>
+                  <a:srgbClr val="53697C"/>
+                </a:solidFill>
+                <a:latin typeface="Noto Sans CJK SC"/>
+              </a:rPr>
+              <a:t>→</a:t>
+            </a:r>
+          </a:p>
+        </p:txBody>
+      </p:sp>
+      <p:sp>
+        <p:nvSpPr>
+          <p:cNvPr id="25" name="h2p-13-box-24"/>
+          <p:cNvSpPr/>
+          <p:nvPr/>
+        </p:nvSpPr>
+        <p:spPr>
+          <a:xfrm>
+            <a:off x="7220102" y="3333902"/>
+            <a:ext cx="590702" cy="267004"/>
+          </a:xfrm>
+          <a:prstGeom prst="roundRect">
+            <a:avLst>
+              <a:gd name="adj" fmla="val 50000"/>
+            </a:avLst>
+          </a:prstGeom>
+          <a:solidFill>
+            <a:srgbClr val="FFFFFF"/>
+          </a:solidFill>
+          <a:ln w="10160">
+            <a:solidFill>
+              <a:srgbClr val="1A8D85"/>
+            </a:solidFill>
+          </a:ln>
+          <a:effectLst/>
+        </p:spPr>
+        <p:style>
+          <a:lnRef idx="1">
+            <a:schemeClr val="accent1"/>
+          </a:lnRef>
+          <a:fillRef idx="3">
+            <a:schemeClr val="accent1"/>
+          </a:fillRef>
+          <a:effectRef idx="0">
+            <a:schemeClr val="accent1"/>
+          </a:effectRef>
+          <a:fontRef idx="minor">
+            <a:schemeClr val="lt1"/>
+          </a:fontRef>
+        </p:style>
+        <p:txBody>
+          <a:bodyPr rtlCol="0" anchor="ctr"/>
+          <a:lstStyle/>
+          <a:p>
+            <a:pPr algn="ctr"/>
+          </a:p>
+        </p:txBody>
+      </p:sp>
+      <p:sp>
+        <p:nvSpPr>
+          <p:cNvPr id="26" name="h2p-13-text-25"/>
+          <p:cNvSpPr txBox="1"/>
+          <p:nvPr/>
+        </p:nvSpPr>
+        <p:spPr>
+          <a:xfrm>
+            <a:off x="7223760" y="3372307"/>
+            <a:ext cx="583387" cy="228600"/>
+          </a:xfrm>
+          <a:prstGeom prst="rect">
+            <a:avLst/>
+          </a:prstGeom>
+          <a:noFill/>
+        </p:spPr>
+        <p:txBody>
+          <a:bodyPr wrap="square" lIns="0" tIns="0" rIns="0" bIns="0">
+            <a:spAutoFit/>
+          </a:bodyPr>
+          <a:lstStyle/>
+          <a:p>
+            <a:pPr marL="0" indent="0" algn="ctr">
+              <a:lnSpc>
+                <a:spcPts val="1440"/>
+              </a:lnSpc>
+              <a:spcBef>
+                <a:spcPts val="0"/>
+              </a:spcBef>
+              <a:spcAft>
+                <a:spcPts val="0"/>
+              </a:spcAft>
+              <a:buNone/>
+            </a:pPr>
+            <a:r>
+              <a:rPr sz="1200">
+                <a:solidFill>
+                  <a:srgbClr val="1A8D85"/>
+                </a:solidFill>
+                <a:latin typeface="Noto Sans CJK SC"/>
+              </a:rPr>
+              <a:t>检索</a:t>
+            </a:r>
+          </a:p>
+        </p:txBody>
+      </p:sp>
+      <p:sp>
+        <p:nvSpPr>
+          <p:cNvPr id="27" name="h2p-13-text-26"/>
+          <p:cNvSpPr txBox="1"/>
+          <p:nvPr/>
+        </p:nvSpPr>
+        <p:spPr>
+          <a:xfrm>
+            <a:off x="7848295" y="3353104"/>
+            <a:ext cx="155448" cy="228600"/>
+          </a:xfrm>
+          <a:prstGeom prst="rect">
+            <a:avLst/>
+          </a:prstGeom>
+          <a:noFill/>
+        </p:spPr>
+        <p:txBody>
+          <a:bodyPr wrap="square" lIns="0" tIns="0" rIns="0" bIns="0">
+            <a:spAutoFit/>
+          </a:bodyPr>
+          <a:lstStyle/>
+          <a:p>
+            <a:pPr marL="0" indent="0" algn="l">
+              <a:lnSpc>
+                <a:spcPts val="1440"/>
+              </a:lnSpc>
+              <a:spcBef>
+                <a:spcPts val="0"/>
+              </a:spcBef>
+              <a:spcAft>
+                <a:spcPts val="0"/>
+              </a:spcAft>
+              <a:buNone/>
+            </a:pPr>
+            <a:r>
+              <a:rPr sz="1200">
+                <a:solidFill>
+                  <a:srgbClr val="53697C"/>
+                </a:solidFill>
+                <a:latin typeface="Noto Sans CJK SC"/>
+              </a:rPr>
+              <a:t>→</a:t>
+            </a:r>
+          </a:p>
+        </p:txBody>
+      </p:sp>
+      <p:sp>
+        <p:nvSpPr>
+          <p:cNvPr id="28" name="h2p-13-box-27"/>
+          <p:cNvSpPr/>
+          <p:nvPr/>
+        </p:nvSpPr>
+        <p:spPr>
+          <a:xfrm>
+            <a:off x="8039404" y="3105302"/>
+            <a:ext cx="1676095" cy="1047902"/>
+          </a:xfrm>
+          <a:prstGeom prst="roundRect">
+            <a:avLst>
+              <a:gd name="adj" fmla="val 10910"/>
+            </a:avLst>
+          </a:prstGeom>
+          <a:solidFill>
+            <a:srgbClr val="FEF6F4"/>
+          </a:solidFill>
+          <a:ln w="19050">
+            <a:solidFill>
+              <a:srgbClr val="F26B4B"/>
+            </a:solidFill>
+            <a:prstDash val="dash"/>
+          </a:ln>
+          <a:effectLst/>
+        </p:spPr>
+        <p:style>
+          <a:lnRef idx="1">
+            <a:schemeClr val="accent1"/>
+          </a:lnRef>
+          <a:fillRef idx="3">
+            <a:schemeClr val="accent1"/>
+          </a:fillRef>
+          <a:effectRef idx="0">
+            <a:schemeClr val="accent1"/>
+          </a:effectRef>
+          <a:fontRef idx="minor">
+            <a:schemeClr val="lt1"/>
+          </a:fontRef>
+        </p:style>
+        <p:txBody>
+          <a:bodyPr rtlCol="0" anchor="ctr"/>
+          <a:lstStyle/>
+          <a:p>
+            <a:pPr algn="ctr"/>
+          </a:p>
+        </p:txBody>
+      </p:sp>
+      <p:sp>
+        <p:nvSpPr>
+          <p:cNvPr id="29" name="h2p-13-text-28"/>
+          <p:cNvSpPr txBox="1"/>
+          <p:nvPr/>
+        </p:nvSpPr>
+        <p:spPr>
+          <a:xfrm>
+            <a:off x="8134502" y="3161995"/>
+            <a:ext cx="1515160" cy="168249"/>
+          </a:xfrm>
+          <a:prstGeom prst="rect">
+            <a:avLst/>
+          </a:prstGeom>
+          <a:noFill/>
+        </p:spPr>
+        <p:txBody>
+          <a:bodyPr wrap="square" lIns="0" tIns="0" rIns="0" bIns="0">
+            <a:spAutoFit/>
+          </a:bodyPr>
+          <a:lstStyle/>
+          <a:p>
+            <a:pPr marL="0" indent="0" algn="l">
+              <a:lnSpc>
+                <a:spcPts val="1320"/>
+              </a:lnSpc>
+              <a:spcBef>
+                <a:spcPts val="0"/>
+              </a:spcBef>
+              <a:spcAft>
+                <a:spcPts val="0"/>
+              </a:spcAft>
+              <a:buNone/>
+            </a:pPr>
+            <a:r>
+              <a:rPr b="1" sz="1050">
+                <a:solidFill>
+                  <a:srgbClr val="C64C32"/>
+                </a:solidFill>
+                <a:latin typeface="Noto Sans CJK SC"/>
+              </a:rPr>
+              <a:t>Π · Agent A₁ 分区</a:t>
+            </a:r>
+          </a:p>
+        </p:txBody>
+      </p:sp>
+      <p:sp>
+        <p:nvSpPr>
+          <p:cNvPr id="30" name="h2p-13-box-29"/>
+          <p:cNvSpPr/>
+          <p:nvPr/>
+        </p:nvSpPr>
+        <p:spPr>
+          <a:xfrm>
+            <a:off x="8134502" y="3409797"/>
+            <a:ext cx="590702" cy="267004"/>
+          </a:xfrm>
+          <a:prstGeom prst="roundRect">
+            <a:avLst>
+              <a:gd name="adj" fmla="val 50000"/>
+            </a:avLst>
+          </a:prstGeom>
+          <a:solidFill>
+            <a:srgbClr val="FFFFFF"/>
+          </a:solidFill>
+          <a:ln w="10160">
+            <a:solidFill>
+              <a:srgbClr val="F26B4B"/>
+            </a:solidFill>
+          </a:ln>
+          <a:effectLst/>
+        </p:spPr>
+        <p:style>
+          <a:lnRef idx="1">
+            <a:schemeClr val="accent1"/>
+          </a:lnRef>
+          <a:fillRef idx="3">
+            <a:schemeClr val="accent1"/>
+          </a:fillRef>
+          <a:effectRef idx="0">
+            <a:schemeClr val="accent1"/>
+          </a:effectRef>
+          <a:fontRef idx="minor">
+            <a:schemeClr val="lt1"/>
+          </a:fontRef>
+        </p:style>
+        <p:txBody>
+          <a:bodyPr rtlCol="0" anchor="ctr"/>
+          <a:lstStyle/>
+          <a:p>
+            <a:pPr algn="ctr"/>
+          </a:p>
+        </p:txBody>
+      </p:sp>
+      <p:sp>
+        <p:nvSpPr>
+          <p:cNvPr id="31" name="h2p-13-text-30"/>
+          <p:cNvSpPr txBox="1"/>
+          <p:nvPr/>
+        </p:nvSpPr>
+        <p:spPr>
+          <a:xfrm>
+            <a:off x="8138160" y="3448202"/>
+            <a:ext cx="583387" cy="228600"/>
+          </a:xfrm>
+          <a:prstGeom prst="rect">
+            <a:avLst/>
+          </a:prstGeom>
+          <a:noFill/>
+        </p:spPr>
+        <p:txBody>
+          <a:bodyPr wrap="square" lIns="0" tIns="0" rIns="0" bIns="0">
+            <a:spAutoFit/>
+          </a:bodyPr>
+          <a:lstStyle/>
+          <a:p>
+            <a:pPr marL="0" indent="0" algn="ctr">
+              <a:lnSpc>
+                <a:spcPts val="1440"/>
+              </a:lnSpc>
+              <a:spcBef>
+                <a:spcPts val="0"/>
+              </a:spcBef>
+              <a:spcAft>
+                <a:spcPts val="0"/>
+              </a:spcAft>
+              <a:buNone/>
+            </a:pPr>
+            <a:r>
+              <a:rPr sz="1200">
+                <a:solidFill>
+                  <a:srgbClr val="F26B4B"/>
+                </a:solidFill>
+                <a:latin typeface="Noto Sans CJK SC"/>
+              </a:rPr>
+              <a:t>定位</a:t>
+            </a:r>
+          </a:p>
+        </p:txBody>
+      </p:sp>
+      <p:sp>
+        <p:nvSpPr>
+          <p:cNvPr id="32" name="h2p-13-text-31"/>
+          <p:cNvSpPr txBox="1"/>
+          <p:nvPr/>
+        </p:nvSpPr>
+        <p:spPr>
+          <a:xfrm>
+            <a:off x="8762695" y="3429000"/>
+            <a:ext cx="155448" cy="228600"/>
+          </a:xfrm>
+          <a:prstGeom prst="rect">
+            <a:avLst/>
+          </a:prstGeom>
+          <a:noFill/>
+        </p:spPr>
+        <p:txBody>
+          <a:bodyPr wrap="square" lIns="0" tIns="0" rIns="0" bIns="0">
+            <a:spAutoFit/>
+          </a:bodyPr>
+          <a:lstStyle/>
+          <a:p>
+            <a:pPr marL="0" indent="0" algn="l">
+              <a:lnSpc>
+                <a:spcPts val="1440"/>
+              </a:lnSpc>
+              <a:spcBef>
+                <a:spcPts val="0"/>
+              </a:spcBef>
+              <a:spcAft>
+                <a:spcPts val="0"/>
+              </a:spcAft>
+              <a:buNone/>
+            </a:pPr>
+            <a:r>
+              <a:rPr sz="1200">
+                <a:solidFill>
+                  <a:srgbClr val="53697C"/>
+                </a:solidFill>
+                <a:latin typeface="Noto Sans CJK SC"/>
+              </a:rPr>
+              <a:t>→</a:t>
+            </a:r>
+          </a:p>
+        </p:txBody>
+      </p:sp>
+      <p:sp>
+        <p:nvSpPr>
+          <p:cNvPr id="33" name="h2p-13-box-32"/>
+          <p:cNvSpPr/>
+          <p:nvPr/>
+        </p:nvSpPr>
+        <p:spPr>
+          <a:xfrm>
+            <a:off x="8953804" y="3409797"/>
+            <a:ext cx="590702" cy="267004"/>
+          </a:xfrm>
+          <a:prstGeom prst="roundRect">
+            <a:avLst>
+              <a:gd name="adj" fmla="val 50000"/>
+            </a:avLst>
+          </a:prstGeom>
+          <a:solidFill>
+            <a:srgbClr val="FFFFFF"/>
+          </a:solidFill>
+          <a:ln w="10160">
+            <a:solidFill>
+              <a:srgbClr val="F26B4B"/>
+            </a:solidFill>
+          </a:ln>
+          <a:effectLst/>
+        </p:spPr>
+        <p:style>
+          <a:lnRef idx="1">
+            <a:schemeClr val="accent1"/>
+          </a:lnRef>
+          <a:fillRef idx="3">
+            <a:schemeClr val="accent1"/>
+          </a:fillRef>
+          <a:effectRef idx="0">
+            <a:schemeClr val="accent1"/>
+          </a:effectRef>
+          <a:fontRef idx="minor">
+            <a:schemeClr val="lt1"/>
+          </a:fontRef>
+        </p:style>
+        <p:txBody>
+          <a:bodyPr rtlCol="0" anchor="ctr"/>
+          <a:lstStyle/>
+          <a:p>
+            <a:pPr algn="ctr"/>
+          </a:p>
+        </p:txBody>
+      </p:sp>
+      <p:sp>
+        <p:nvSpPr>
+          <p:cNvPr id="34" name="h2p-13-text-33"/>
+          <p:cNvSpPr txBox="1"/>
+          <p:nvPr/>
+        </p:nvSpPr>
+        <p:spPr>
+          <a:xfrm>
+            <a:off x="8957462" y="3448202"/>
+            <a:ext cx="583387" cy="228600"/>
+          </a:xfrm>
+          <a:prstGeom prst="rect">
+            <a:avLst/>
+          </a:prstGeom>
+          <a:noFill/>
+        </p:spPr>
+        <p:txBody>
+          <a:bodyPr wrap="square" lIns="0" tIns="0" rIns="0" bIns="0">
+            <a:spAutoFit/>
+          </a:bodyPr>
+          <a:lstStyle/>
+          <a:p>
+            <a:pPr marL="0" indent="0" algn="ctr">
+              <a:lnSpc>
+                <a:spcPts val="1440"/>
+              </a:lnSpc>
+              <a:spcBef>
+                <a:spcPts val="0"/>
+              </a:spcBef>
+              <a:spcAft>
+                <a:spcPts val="0"/>
+              </a:spcAft>
+              <a:buNone/>
+            </a:pPr>
+            <a:r>
+              <a:rPr sz="1200">
+                <a:solidFill>
+                  <a:srgbClr val="F26B4B"/>
+                </a:solidFill>
+                <a:latin typeface="Noto Sans CJK SC"/>
+              </a:rPr>
+              <a:t>生成</a:t>
+            </a:r>
+          </a:p>
+        </p:txBody>
+      </p:sp>
+      <p:sp>
+        <p:nvSpPr>
+          <p:cNvPr id="35" name="h2p-13-box-34"/>
+          <p:cNvSpPr/>
+          <p:nvPr/>
+        </p:nvSpPr>
+        <p:spPr>
+          <a:xfrm>
+            <a:off x="8343900" y="3781044"/>
+            <a:ext cx="1067104" cy="19202"/>
+          </a:xfrm>
+          <a:prstGeom prst="rect">
+            <a:avLst/>
+          </a:prstGeom>
+          <a:solidFill>
+            <a:srgbClr val="1A8D85"/>
+          </a:solidFill>
+          <a:ln>
+            <a:noFill/>
+          </a:ln>
+          <a:effectLst/>
+        </p:spPr>
+        <p:style>
+          <a:lnRef idx="1">
+            <a:schemeClr val="accent1"/>
+          </a:lnRef>
+          <a:fillRef idx="3">
+            <a:schemeClr val="accent1"/>
+          </a:fillRef>
+          <a:effectRef idx="0">
+            <a:schemeClr val="accent1"/>
+          </a:effectRef>
+          <a:fontRef idx="minor">
+            <a:schemeClr val="lt1"/>
+          </a:fontRef>
+        </p:style>
+        <p:txBody>
+          <a:bodyPr rtlCol="0" anchor="ctr"/>
+          <a:lstStyle/>
+          <a:p>
+            <a:pPr algn="ctr"/>
+          </a:p>
+        </p:txBody>
+      </p:sp>
+      <p:sp>
+        <p:nvSpPr>
+          <p:cNvPr id="36" name="h2p-13-text-35"/>
+          <p:cNvSpPr txBox="1"/>
+          <p:nvPr/>
+        </p:nvSpPr>
+        <p:spPr>
+          <a:xfrm>
+            <a:off x="8172907" y="3657600"/>
+            <a:ext cx="155448" cy="152704"/>
+          </a:xfrm>
+          <a:prstGeom prst="rect">
+            <a:avLst/>
+          </a:prstGeom>
+          <a:noFill/>
+        </p:spPr>
+        <p:txBody>
+          <a:bodyPr wrap="square" lIns="0" tIns="0" rIns="0" bIns="0">
+            <a:spAutoFit/>
+          </a:bodyPr>
+          <a:lstStyle/>
+          <a:p>
+            <a:pPr marL="0" indent="0" algn="l">
+              <a:lnSpc>
+                <a:spcPts val="1200"/>
+              </a:lnSpc>
+              <a:spcBef>
+                <a:spcPts val="0"/>
+              </a:spcBef>
+              <a:spcAft>
+                <a:spcPts val="0"/>
+              </a:spcAft>
+              <a:buNone/>
+            </a:pPr>
+            <a:r>
+              <a:rPr b="1" sz="1200">
+                <a:solidFill>
+                  <a:srgbClr val="1A8D85"/>
+                </a:solidFill>
+                <a:latin typeface="Noto Sans CJK SC"/>
+              </a:rPr>
+              <a:t>←</a:t>
+            </a:r>
+          </a:p>
+        </p:txBody>
+      </p:sp>
+      <p:sp>
+        <p:nvSpPr>
+          <p:cNvPr id="37" name="h2p-13-text-36"/>
+          <p:cNvSpPr txBox="1"/>
+          <p:nvPr/>
+        </p:nvSpPr>
+        <p:spPr>
+          <a:xfrm>
+            <a:off x="8134502" y="3886200"/>
+            <a:ext cx="1515160" cy="311810"/>
+          </a:xfrm>
+          <a:prstGeom prst="rect">
+            <a:avLst/>
+          </a:prstGeom>
+          <a:noFill/>
+        </p:spPr>
+        <p:txBody>
+          <a:bodyPr wrap="square" lIns="0" tIns="0" rIns="0" bIns="0">
+            <a:spAutoFit/>
+          </a:bodyPr>
+          <a:lstStyle/>
+          <a:p>
+            <a:pPr marL="0" indent="0" algn="l">
+              <a:lnSpc>
+                <a:spcPts val="1230"/>
+              </a:lnSpc>
+              <a:spcBef>
+                <a:spcPts val="0"/>
+              </a:spcBef>
+              <a:spcAft>
+                <a:spcPts val="0"/>
+              </a:spcAft>
+              <a:buNone/>
+            </a:pPr>
+            <a:r>
+              <a:rPr b="1" sz="980">
+                <a:solidFill>
+                  <a:srgbClr val="1A8D85"/>
+                </a:solidFill>
+                <a:latin typeface="Noto Sans CJK SC"/>
+              </a:rPr>
+              <a:t>生成 → 定位 · 最多 3 次 · 未通过退出</a:t>
+            </a:r>
+          </a:p>
+        </p:txBody>
+      </p:sp>
+      <p:sp>
+        <p:nvSpPr>
+          <p:cNvPr id="38" name="h2p-13-text-37"/>
+          <p:cNvSpPr txBox="1"/>
+          <p:nvPr/>
+        </p:nvSpPr>
+        <p:spPr>
+          <a:xfrm>
+            <a:off x="9753904" y="3429000"/>
+            <a:ext cx="155448" cy="228600"/>
+          </a:xfrm>
+          <a:prstGeom prst="rect">
+            <a:avLst/>
+          </a:prstGeom>
+          <a:noFill/>
+        </p:spPr>
+        <p:txBody>
+          <a:bodyPr wrap="square" lIns="0" tIns="0" rIns="0" bIns="0">
+            <a:spAutoFit/>
+          </a:bodyPr>
+          <a:lstStyle/>
+          <a:p>
+            <a:pPr marL="0" indent="0" algn="l">
+              <a:lnSpc>
+                <a:spcPts val="1440"/>
+              </a:lnSpc>
+              <a:spcBef>
+                <a:spcPts val="0"/>
+              </a:spcBef>
+              <a:spcAft>
+                <a:spcPts val="0"/>
+              </a:spcAft>
+              <a:buNone/>
+            </a:pPr>
+            <a:r>
+              <a:rPr sz="1200">
+                <a:solidFill>
+                  <a:srgbClr val="53697C"/>
+                </a:solidFill>
+                <a:latin typeface="Noto Sans CJK SC"/>
+              </a:rPr>
+              <a:t>→</a:t>
+            </a:r>
+          </a:p>
+        </p:txBody>
+      </p:sp>
+      <p:sp>
+        <p:nvSpPr>
+          <p:cNvPr id="39" name="h2p-13-box-38"/>
+          <p:cNvSpPr/>
+          <p:nvPr/>
+        </p:nvSpPr>
+        <p:spPr>
+          <a:xfrm>
+            <a:off x="9944100" y="3409797"/>
+            <a:ext cx="590702" cy="267004"/>
+          </a:xfrm>
+          <a:prstGeom prst="roundRect">
+            <a:avLst>
+              <a:gd name="adj" fmla="val 50000"/>
+            </a:avLst>
+          </a:prstGeom>
+          <a:solidFill>
+            <a:srgbClr val="FFFFFF"/>
+          </a:solidFill>
+          <a:ln w="10160">
+            <a:solidFill>
+              <a:srgbClr val="1A8D85"/>
+            </a:solidFill>
+          </a:ln>
+          <a:effectLst/>
+        </p:spPr>
+        <p:style>
+          <a:lnRef idx="1">
+            <a:schemeClr val="accent1"/>
+          </a:lnRef>
+          <a:fillRef idx="3">
+            <a:schemeClr val="accent1"/>
+          </a:fillRef>
+          <a:effectRef idx="0">
+            <a:schemeClr val="accent1"/>
+          </a:effectRef>
+          <a:fontRef idx="minor">
+            <a:schemeClr val="lt1"/>
+          </a:fontRef>
+        </p:style>
+        <p:txBody>
+          <a:bodyPr rtlCol="0" anchor="ctr"/>
+          <a:lstStyle/>
+          <a:p>
+            <a:pPr algn="ctr"/>
+          </a:p>
+        </p:txBody>
+      </p:sp>
+      <p:sp>
+        <p:nvSpPr>
+          <p:cNvPr id="40" name="h2p-13-text-39"/>
+          <p:cNvSpPr txBox="1"/>
+          <p:nvPr/>
+        </p:nvSpPr>
+        <p:spPr>
+          <a:xfrm>
+            <a:off x="9947757" y="3448202"/>
+            <a:ext cx="583387" cy="228600"/>
+          </a:xfrm>
+          <a:prstGeom prst="rect">
+            <a:avLst/>
+          </a:prstGeom>
+          <a:noFill/>
+        </p:spPr>
+        <p:txBody>
+          <a:bodyPr wrap="square" lIns="0" tIns="0" rIns="0" bIns="0">
+            <a:spAutoFit/>
+          </a:bodyPr>
+          <a:lstStyle/>
+          <a:p>
+            <a:pPr marL="0" indent="0" algn="ctr">
+              <a:lnSpc>
+                <a:spcPts val="1440"/>
+              </a:lnSpc>
+              <a:spcBef>
+                <a:spcPts val="0"/>
+              </a:spcBef>
+              <a:spcAft>
+                <a:spcPts val="0"/>
+              </a:spcAft>
+              <a:buNone/>
+            </a:pPr>
+            <a:r>
+              <a:rPr sz="1200">
+                <a:solidFill>
+                  <a:srgbClr val="1A8D85"/>
+                </a:solidFill>
+                <a:latin typeface="Noto Sans CJK SC"/>
+              </a:rPr>
+              <a:t>测试</a:t>
+            </a:r>
+          </a:p>
+        </p:txBody>
+      </p:sp>
+      <p:sp>
+        <p:nvSpPr>
+          <p:cNvPr id="41" name="h2p-13-text-40"/>
+          <p:cNvSpPr txBox="1"/>
+          <p:nvPr/>
+        </p:nvSpPr>
+        <p:spPr>
+          <a:xfrm>
+            <a:off x="10572292" y="3429000"/>
+            <a:ext cx="155448" cy="228600"/>
+          </a:xfrm>
+          <a:prstGeom prst="rect">
+            <a:avLst/>
+          </a:prstGeom>
+          <a:noFill/>
+        </p:spPr>
+        <p:txBody>
+          <a:bodyPr wrap="square" lIns="0" tIns="0" rIns="0" bIns="0">
+            <a:spAutoFit/>
+          </a:bodyPr>
+          <a:lstStyle/>
+          <a:p>
+            <a:pPr marL="0" indent="0" algn="l">
+              <a:lnSpc>
+                <a:spcPts val="1440"/>
+              </a:lnSpc>
+              <a:spcBef>
+                <a:spcPts val="0"/>
+              </a:spcBef>
+              <a:spcAft>
+                <a:spcPts val="0"/>
+              </a:spcAft>
+              <a:buNone/>
+            </a:pPr>
+            <a:r>
+              <a:rPr sz="1200">
+                <a:solidFill>
+                  <a:srgbClr val="53697C"/>
+                </a:solidFill>
+                <a:latin typeface="Noto Sans CJK SC"/>
+              </a:rPr>
+              <a:t>→</a:t>
+            </a:r>
+          </a:p>
+        </p:txBody>
+      </p:sp>
+      <p:sp>
+        <p:nvSpPr>
+          <p:cNvPr id="42" name="h2p-13-box-41"/>
+          <p:cNvSpPr/>
+          <p:nvPr/>
+        </p:nvSpPr>
+        <p:spPr>
+          <a:xfrm>
+            <a:off x="10763402" y="3409797"/>
+            <a:ext cx="590702" cy="267004"/>
+          </a:xfrm>
+          <a:prstGeom prst="roundRect">
+            <a:avLst>
+              <a:gd name="adj" fmla="val 50000"/>
+            </a:avLst>
+          </a:prstGeom>
+          <a:solidFill>
+            <a:srgbClr val="FFFFFF"/>
+          </a:solidFill>
+          <a:ln w="10160">
+            <a:solidFill>
+              <a:srgbClr val="D6A43B"/>
+            </a:solidFill>
+          </a:ln>
+          <a:effectLst/>
+        </p:spPr>
+        <p:style>
+          <a:lnRef idx="1">
+            <a:schemeClr val="accent1"/>
+          </a:lnRef>
+          <a:fillRef idx="3">
+            <a:schemeClr val="accent1"/>
+          </a:fillRef>
+          <a:effectRef idx="0">
+            <a:schemeClr val="accent1"/>
+          </a:effectRef>
+          <a:fontRef idx="minor">
+            <a:schemeClr val="lt1"/>
+          </a:fontRef>
+        </p:style>
+        <p:txBody>
+          <a:bodyPr rtlCol="0" anchor="ctr"/>
+          <a:lstStyle/>
+          <a:p>
+            <a:pPr algn="ctr"/>
+          </a:p>
+        </p:txBody>
+      </p:sp>
+      <p:sp>
+        <p:nvSpPr>
+          <p:cNvPr id="43" name="h2p-13-text-42"/>
+          <p:cNvSpPr txBox="1"/>
+          <p:nvPr/>
+        </p:nvSpPr>
+        <p:spPr>
+          <a:xfrm>
+            <a:off x="10767060" y="3448202"/>
+            <a:ext cx="583387" cy="228600"/>
+          </a:xfrm>
+          <a:prstGeom prst="rect">
+            <a:avLst/>
+          </a:prstGeom>
+          <a:noFill/>
+        </p:spPr>
+        <p:txBody>
+          <a:bodyPr wrap="square" lIns="0" tIns="0" rIns="0" bIns="0">
+            <a:spAutoFit/>
+          </a:bodyPr>
+          <a:lstStyle/>
+          <a:p>
+            <a:pPr marL="0" indent="0" algn="ctr">
+              <a:lnSpc>
+                <a:spcPts val="1440"/>
+              </a:lnSpc>
+              <a:spcBef>
+                <a:spcPts val="0"/>
+              </a:spcBef>
+              <a:spcAft>
+                <a:spcPts val="0"/>
+              </a:spcAft>
+              <a:buNone/>
+            </a:pPr>
+            <a:r>
+              <a:rPr sz="1200">
+                <a:solidFill>
+                  <a:srgbClr val="A5781C"/>
+                </a:solidFill>
+                <a:latin typeface="Noto Sans CJK SC"/>
+              </a:rPr>
+              <a:t>人工</a:t>
+            </a:r>
+          </a:p>
+        </p:txBody>
+      </p:sp>
+      <p:sp>
+        <p:nvSpPr>
+          <p:cNvPr id="44" name="h2p-13-text-43"/>
+          <p:cNvSpPr txBox="1"/>
+          <p:nvPr/>
+        </p:nvSpPr>
+        <p:spPr>
+          <a:xfrm>
+            <a:off x="6400800" y="4248302"/>
+            <a:ext cx="4955133" cy="172821"/>
+          </a:xfrm>
+          <a:prstGeom prst="rect">
+            <a:avLst/>
+          </a:prstGeom>
+          <a:noFill/>
+        </p:spPr>
+        <p:txBody>
+          <a:bodyPr wrap="square" lIns="0" tIns="0" rIns="0" bIns="0">
+            <a:spAutoFit/>
+          </a:bodyPr>
+          <a:lstStyle/>
+          <a:p>
+            <a:pPr marL="0" indent="0" algn="l">
+              <a:lnSpc>
+                <a:spcPts val="1360"/>
+              </a:lnSpc>
+              <a:spcBef>
+                <a:spcPts val="0"/>
+              </a:spcBef>
+              <a:spcAft>
+                <a:spcPts val="0"/>
+              </a:spcAft>
+              <a:buNone/>
+            </a:pPr>
+            <a:r>
+              <a:rPr sz="1050">
+                <a:solidFill>
+                  <a:srgbClr val="53697C"/>
+                </a:solidFill>
+                <a:latin typeface="Noto Sans CJK SC"/>
+              </a:rPr>
+              <a:t>主干顺序推进；局部返回边形成 SCC，并由重试上限终止。</a:t>
+            </a:r>
+          </a:p>
+        </p:txBody>
+      </p:sp>
+      <p:sp>
+        <p:nvSpPr>
+          <p:cNvPr id="45" name="h2p-13-text-44"/>
+          <p:cNvSpPr txBox="1"/>
+          <p:nvPr/>
+        </p:nvSpPr>
+        <p:spPr>
+          <a:xfrm>
+            <a:off x="6400800" y="4457700"/>
+            <a:ext cx="4955133" cy="160934"/>
+          </a:xfrm>
+          <a:prstGeom prst="rect">
+            <a:avLst/>
+          </a:prstGeom>
+          <a:noFill/>
+        </p:spPr>
+        <p:txBody>
+          <a:bodyPr wrap="square" lIns="0" tIns="0" rIns="0" bIns="0">
+            <a:spAutoFit/>
+          </a:bodyPr>
+          <a:lstStyle/>
+          <a:p>
+            <a:pPr marL="0" indent="0" algn="l">
+              <a:lnSpc>
+                <a:spcPts val="1270"/>
+              </a:lnSpc>
+              <a:spcBef>
+                <a:spcPts val="0"/>
+              </a:spcBef>
+              <a:spcAft>
+                <a:spcPts val="0"/>
+              </a:spcAft>
+              <a:buNone/>
+            </a:pPr>
+            <a:r>
+              <a:rPr sz="980">
+                <a:solidFill>
+                  <a:srgbClr val="53697C"/>
+                </a:solidFill>
+                <a:latin typeface="Noto Sans CJK SC"/>
+              </a:rPr>
+              <a:t>θ = Prompt / 阈值 / 重试 · ρ = 仓库 / 记忆 / 通信的共享边界</a:t>
+            </a:r>
+          </a:p>
+        </p:txBody>
+      </p:sp>
+      <p:sp>
+        <p:nvSpPr>
+          <p:cNvPr id="46" name="h2p-13-box-45"/>
+          <p:cNvSpPr/>
+          <p:nvPr/>
+        </p:nvSpPr>
+        <p:spPr>
+          <a:xfrm>
+            <a:off x="6172200" y="4781397"/>
+            <a:ext cx="2571292" cy="1695297"/>
+          </a:xfrm>
+          <a:prstGeom prst="roundRect">
+            <a:avLst>
+              <a:gd name="adj" fmla="val 10110"/>
             </a:avLst>
           </a:prstGeom>
           <a:solidFill>
@@ -9466,40 +10629,40 @@
       </p:sp>
       <p:sp>
         <p:nvSpPr>
-          <p:cNvPr id="22" name="h2p-13-text-21"/>
-          <p:cNvSpPr txBox="1"/>
-          <p:nvPr/>
-        </p:nvSpPr>
-        <p:spPr>
-          <a:xfrm>
-            <a:off x="6400800" y="3353104"/>
-            <a:ext cx="2195474" cy="160020"/>
-          </a:xfrm>
-          <a:prstGeom prst="rect">
-            <a:avLst/>
-          </a:prstGeom>
-          <a:noFill/>
-        </p:spPr>
-        <p:txBody>
-          <a:bodyPr wrap="square" lIns="0" tIns="0" rIns="0" bIns="0">
-            <a:spAutoFit/>
-          </a:bodyPr>
-          <a:lstStyle/>
-          <a:p>
-            <a:pPr marL="0" indent="0" algn="l">
-              <a:lnSpc>
-                <a:spcPts val="1260"/>
-              </a:lnSpc>
-              <a:spcBef>
-                <a:spcPts val="0"/>
-              </a:spcBef>
-              <a:spcAft>
-                <a:spcPts val="0"/>
-              </a:spcAft>
-              <a:buNone/>
-            </a:pPr>
-            <a:r>
-              <a:rPr b="1" sz="1050">
+          <p:cNvPr id="47" name="h2p-13-text-46"/>
+          <p:cNvSpPr txBox="1"/>
+          <p:nvPr/>
+        </p:nvSpPr>
+        <p:spPr>
+          <a:xfrm>
+            <a:off x="6400800" y="4914900"/>
+            <a:ext cx="2195474" cy="125272"/>
+          </a:xfrm>
+          <a:prstGeom prst="rect">
+            <a:avLst/>
+          </a:prstGeom>
+          <a:noFill/>
+        </p:spPr>
+        <p:txBody>
+          <a:bodyPr wrap="square" lIns="0" tIns="0" rIns="0" bIns="0">
+            <a:spAutoFit/>
+          </a:bodyPr>
+          <a:lstStyle/>
+          <a:p>
+            <a:pPr marL="0" indent="0" algn="l">
+              <a:lnSpc>
+                <a:spcPts val="990"/>
+              </a:lnSpc>
+              <a:spcBef>
+                <a:spcPts val="0"/>
+              </a:spcBef>
+              <a:spcAft>
+                <a:spcPts val="0"/>
+              </a:spcAft>
+              <a:buNone/>
+            </a:pPr>
+            <a:r>
+              <a:rPr b="1" sz="819">
                 <a:solidFill>
                   <a:srgbClr val="1A8D85"/>
                 </a:solidFill>
@@ -9512,40 +10675,40 @@
       </p:sp>
       <p:sp>
         <p:nvSpPr>
-          <p:cNvPr id="23" name="h2p-13-text-22"/>
-          <p:cNvSpPr txBox="1"/>
-          <p:nvPr/>
-        </p:nvSpPr>
-        <p:spPr>
-          <a:xfrm>
-            <a:off x="6400800" y="3676802"/>
-            <a:ext cx="2195474" cy="202082"/>
-          </a:xfrm>
-          <a:prstGeom prst="rect">
-            <a:avLst/>
-          </a:prstGeom>
-          <a:noFill/>
-        </p:spPr>
-        <p:txBody>
-          <a:bodyPr wrap="square" lIns="0" tIns="0" rIns="0" bIns="0">
-            <a:spAutoFit/>
-          </a:bodyPr>
-          <a:lstStyle/>
-          <a:p>
-            <a:pPr marL="0" indent="0" algn="l">
-              <a:lnSpc>
-                <a:spcPts val="1590"/>
-              </a:lnSpc>
-              <a:spcBef>
-                <a:spcPts val="0"/>
-              </a:spcBef>
-              <a:spcAft>
-                <a:spcPts val="0"/>
-              </a:spcAft>
-              <a:buNone/>
-            </a:pPr>
-            <a:r>
-              <a:rPr b="1" sz="1350">
+          <p:cNvPr id="48" name="h2p-13-text-47"/>
+          <p:cNvSpPr txBox="1"/>
+          <p:nvPr/>
+        </p:nvSpPr>
+        <p:spPr>
+          <a:xfrm>
+            <a:off x="6400800" y="5143500"/>
+            <a:ext cx="2195474" cy="168249"/>
+          </a:xfrm>
+          <a:prstGeom prst="rect">
+            <a:avLst/>
+          </a:prstGeom>
+          <a:noFill/>
+        </p:spPr>
+        <p:txBody>
+          <a:bodyPr wrap="square" lIns="0" tIns="0" rIns="0" bIns="0">
+            <a:spAutoFit/>
+          </a:bodyPr>
+          <a:lstStyle/>
+          <a:p>
+            <a:pPr marL="0" indent="0" algn="l">
+              <a:lnSpc>
+                <a:spcPts val="1330"/>
+              </a:lnSpc>
+              <a:spcBef>
+                <a:spcPts val="0"/>
+              </a:spcBef>
+              <a:spcAft>
+                <a:spcPts val="0"/>
+              </a:spcAft>
+              <a:buNone/>
+            </a:pPr>
+            <a:r>
+              <a:rPr b="1" sz="1120">
                 <a:solidFill>
                   <a:srgbClr val="102A43"/>
                 </a:solidFill>
@@ -9558,59 +10721,59 @@
       </p:sp>
       <p:sp>
         <p:nvSpPr>
-          <p:cNvPr id="24" name="h2p-13-text-23"/>
-          <p:cNvSpPr txBox="1"/>
-          <p:nvPr/>
-        </p:nvSpPr>
-        <p:spPr>
-          <a:xfrm>
-            <a:off x="6400800" y="4038904"/>
-            <a:ext cx="2195474" cy="346557"/>
-          </a:xfrm>
-          <a:prstGeom prst="rect">
-            <a:avLst/>
-          </a:prstGeom>
-          <a:noFill/>
-        </p:spPr>
-        <p:txBody>
-          <a:bodyPr wrap="square" lIns="0" tIns="0" rIns="0" bIns="0">
-            <a:spAutoFit/>
-          </a:bodyPr>
-          <a:lstStyle/>
-          <a:p>
-            <a:pPr marL="0" indent="0" algn="l">
-              <a:lnSpc>
-                <a:spcPts val="1360"/>
-              </a:lnSpc>
-              <a:spcBef>
-                <a:spcPts val="0"/>
-              </a:spcBef>
-              <a:spcAft>
-                <a:spcPts val="0"/>
-              </a:spcAft>
-              <a:buNone/>
-            </a:pPr>
-            <a:r>
-              <a:rPr sz="980">
+          <p:cNvPr id="49" name="h2p-13-text-48"/>
+          <p:cNvSpPr txBox="1"/>
+          <p:nvPr/>
+        </p:nvSpPr>
+        <p:spPr>
+          <a:xfrm>
+            <a:off x="6400800" y="5391302"/>
+            <a:ext cx="2195474" cy="360273"/>
+          </a:xfrm>
+          <a:prstGeom prst="rect">
+            <a:avLst/>
+          </a:prstGeom>
+          <a:noFill/>
+        </p:spPr>
+        <p:txBody>
+          <a:bodyPr wrap="square" lIns="0" tIns="0" rIns="0" bIns="0">
+            <a:spAutoFit/>
+          </a:bodyPr>
+          <a:lstStyle/>
+          <a:p>
+            <a:pPr marL="0" indent="0" algn="l">
+              <a:lnSpc>
+                <a:spcPts val="1420"/>
+              </a:lnSpc>
+              <a:spcBef>
+                <a:spcPts val="0"/>
+              </a:spcBef>
+              <a:spcAft>
+                <a:spcPts val="0"/>
+              </a:spcAft>
+              <a:buNone/>
+            </a:pPr>
+            <a:r>
+              <a:rPr sz="1050">
                 <a:solidFill>
                   <a:srgbClr val="53697C"/>
                 </a:solidFill>
                 <a:latin typeface="Noto Sans CJK SC"/>
               </a:rPr>
-              <a:t>固定 G / Π；更新 θ / ρ；遍历 adaptation samples。</a:t>
-            </a:r>
-          </a:p>
-        </p:txBody>
-      </p:sp>
-      <p:sp>
-        <p:nvSpPr>
-          <p:cNvPr id="25" name="h2p-13-text-24"/>
-          <p:cNvSpPr txBox="1"/>
-          <p:nvPr/>
-        </p:nvSpPr>
-        <p:spPr>
-          <a:xfrm>
-            <a:off x="6400800" y="4762195"/>
+              <a:t>固定 G / Π / ρ；只更新 θ 与分区内状态；遍历 adaptation samples。</a:t>
+            </a:r>
+          </a:p>
+        </p:txBody>
+      </p:sp>
+      <p:sp>
+        <p:nvSpPr>
+          <p:cNvPr id="50" name="h2p-13-text-49"/>
+          <p:cNvSpPr txBox="1"/>
+          <p:nvPr/>
+        </p:nvSpPr>
+        <p:spPr>
+          <a:xfrm>
+            <a:off x="6400800" y="6077102"/>
             <a:ext cx="2195474" cy="156362"/>
           </a:xfrm>
           <a:prstGeom prst="rect">
@@ -9650,18 +10813,18 @@
       </p:sp>
       <p:sp>
         <p:nvSpPr>
-          <p:cNvPr id="26" name="h2p-13-box-25"/>
+          <p:cNvPr id="51" name="h2p-13-box-50"/>
           <p:cNvSpPr/>
           <p:nvPr/>
         </p:nvSpPr>
         <p:spPr>
           <a:xfrm>
-            <a:off x="8934602" y="3219602"/>
-            <a:ext cx="2571292" cy="1981504"/>
+            <a:off x="8934602" y="4781397"/>
+            <a:ext cx="2571292" cy="1695297"/>
           </a:xfrm>
           <a:prstGeom prst="roundRect">
             <a:avLst>
-              <a:gd name="adj" fmla="val 8650"/>
+              <a:gd name="adj" fmla="val 10110"/>
             </a:avLst>
           </a:prstGeom>
           <a:solidFill>
@@ -9698,40 +10861,40 @@
       </p:sp>
       <p:sp>
         <p:nvSpPr>
-          <p:cNvPr id="27" name="h2p-13-text-26"/>
-          <p:cNvSpPr txBox="1"/>
-          <p:nvPr/>
-        </p:nvSpPr>
-        <p:spPr>
-          <a:xfrm>
-            <a:off x="9163202" y="3353104"/>
-            <a:ext cx="2195474" cy="160020"/>
-          </a:xfrm>
-          <a:prstGeom prst="rect">
-            <a:avLst/>
-          </a:prstGeom>
-          <a:noFill/>
-        </p:spPr>
-        <p:txBody>
-          <a:bodyPr wrap="square" lIns="0" tIns="0" rIns="0" bIns="0">
-            <a:spAutoFit/>
-          </a:bodyPr>
-          <a:lstStyle/>
-          <a:p>
-            <a:pPr marL="0" indent="0" algn="l">
-              <a:lnSpc>
-                <a:spcPts val="1260"/>
-              </a:lnSpc>
-              <a:spcBef>
-                <a:spcPts val="0"/>
-              </a:spcBef>
-              <a:spcAft>
-                <a:spcPts val="0"/>
-              </a:spcAft>
-              <a:buNone/>
-            </a:pPr>
-            <a:r>
-              <a:rPr b="1" sz="1050">
+          <p:cNvPr id="52" name="h2p-13-text-51"/>
+          <p:cNvSpPr txBox="1"/>
+          <p:nvPr/>
+        </p:nvSpPr>
+        <p:spPr>
+          <a:xfrm>
+            <a:off x="9163202" y="4914900"/>
+            <a:ext cx="2195474" cy="125272"/>
+          </a:xfrm>
+          <a:prstGeom prst="rect">
+            <a:avLst/>
+          </a:prstGeom>
+          <a:noFill/>
+        </p:spPr>
+        <p:txBody>
+          <a:bodyPr wrap="square" lIns="0" tIns="0" rIns="0" bIns="0">
+            <a:spAutoFit/>
+          </a:bodyPr>
+          <a:lstStyle/>
+          <a:p>
+            <a:pPr marL="0" indent="0" algn="l">
+              <a:lnSpc>
+                <a:spcPts val="990"/>
+              </a:lnSpc>
+              <a:spcBef>
+                <a:spcPts val="0"/>
+              </a:spcBef>
+              <a:spcAft>
+                <a:spcPts val="0"/>
+              </a:spcAft>
+              <a:buNone/>
+            </a:pPr>
+            <a:r>
+              <a:rPr b="1" sz="819">
                 <a:solidFill>
                   <a:srgbClr val="C64C32"/>
                 </a:solidFill>
@@ -9744,40 +10907,40 @@
       </p:sp>
       <p:sp>
         <p:nvSpPr>
-          <p:cNvPr id="28" name="h2p-13-text-27"/>
-          <p:cNvSpPr txBox="1"/>
-          <p:nvPr/>
-        </p:nvSpPr>
-        <p:spPr>
-          <a:xfrm>
-            <a:off x="9163202" y="3676802"/>
-            <a:ext cx="2195474" cy="202082"/>
-          </a:xfrm>
-          <a:prstGeom prst="rect">
-            <a:avLst/>
-          </a:prstGeom>
-          <a:noFill/>
-        </p:spPr>
-        <p:txBody>
-          <a:bodyPr wrap="square" lIns="0" tIns="0" rIns="0" bIns="0">
-            <a:spAutoFit/>
-          </a:bodyPr>
-          <a:lstStyle/>
-          <a:p>
-            <a:pPr marL="0" indent="0" algn="l">
-              <a:lnSpc>
-                <a:spcPts val="1590"/>
-              </a:lnSpc>
-              <a:spcBef>
-                <a:spcPts val="0"/>
-              </a:spcBef>
-              <a:spcAft>
-                <a:spcPts val="0"/>
-              </a:spcAft>
-              <a:buNone/>
-            </a:pPr>
-            <a:r>
-              <a:rPr b="1" sz="1350">
+          <p:cNvPr id="53" name="h2p-13-text-52"/>
+          <p:cNvSpPr txBox="1"/>
+          <p:nvPr/>
+        </p:nvSpPr>
+        <p:spPr>
+          <a:xfrm>
+            <a:off x="9163202" y="5143500"/>
+            <a:ext cx="2195474" cy="168249"/>
+          </a:xfrm>
+          <a:prstGeom prst="rect">
+            <a:avLst/>
+          </a:prstGeom>
+          <a:noFill/>
+        </p:spPr>
+        <p:txBody>
+          <a:bodyPr wrap="square" lIns="0" tIns="0" rIns="0" bIns="0">
+            <a:spAutoFit/>
+          </a:bodyPr>
+          <a:lstStyle/>
+          <a:p>
+            <a:pPr marL="0" indent="0" algn="l">
+              <a:lnSpc>
+                <a:spcPts val="1330"/>
+              </a:lnSpc>
+              <a:spcBef>
+                <a:spcPts val="0"/>
+              </a:spcBef>
+              <a:spcAft>
+                <a:spcPts val="0"/>
+              </a:spcAft>
+              <a:buNone/>
+            </a:pPr>
+            <a:r>
+              <a:rPr b="1" sz="1120">
                 <a:solidFill>
                   <a:srgbClr val="102A43"/>
                 </a:solidFill>
@@ -9790,59 +10953,59 @@
       </p:sp>
       <p:sp>
         <p:nvSpPr>
-          <p:cNvPr id="29" name="h2p-13-text-28"/>
-          <p:cNvSpPr txBox="1"/>
-          <p:nvPr/>
-        </p:nvSpPr>
-        <p:spPr>
-          <a:xfrm>
-            <a:off x="9163202" y="4038904"/>
-            <a:ext cx="2195474" cy="346557"/>
-          </a:xfrm>
-          <a:prstGeom prst="rect">
-            <a:avLst/>
-          </a:prstGeom>
-          <a:noFill/>
-        </p:spPr>
-        <p:txBody>
-          <a:bodyPr wrap="square" lIns="0" tIns="0" rIns="0" bIns="0">
-            <a:spAutoFit/>
-          </a:bodyPr>
-          <a:lstStyle/>
-          <a:p>
-            <a:pPr marL="0" indent="0" algn="l">
-              <a:lnSpc>
-                <a:spcPts val="1360"/>
-              </a:lnSpc>
-              <a:spcBef>
-                <a:spcPts val="0"/>
-              </a:spcBef>
-              <a:spcAft>
-                <a:spcPts val="0"/>
-              </a:spcAft>
-              <a:buNone/>
-            </a:pPr>
-            <a:r>
-              <a:rPr sz="980">
+          <p:cNvPr id="54" name="h2p-13-text-53"/>
+          <p:cNvSpPr txBox="1"/>
+          <p:nvPr/>
+        </p:nvSpPr>
+        <p:spPr>
+          <a:xfrm>
+            <a:off x="9163202" y="5391302"/>
+            <a:ext cx="2195474" cy="360273"/>
+          </a:xfrm>
+          <a:prstGeom prst="rect">
+            <a:avLst/>
+          </a:prstGeom>
+          <a:noFill/>
+        </p:spPr>
+        <p:txBody>
+          <a:bodyPr wrap="square" lIns="0" tIns="0" rIns="0" bIns="0">
+            <a:spAutoFit/>
+          </a:bodyPr>
+          <a:lstStyle/>
+          <a:p>
+            <a:pPr marL="0" indent="0" algn="l">
+              <a:lnSpc>
+                <a:spcPts val="1420"/>
+              </a:lnSpc>
+              <a:spcBef>
+                <a:spcPts val="0"/>
+              </a:spcBef>
+              <a:spcAft>
+                <a:spcPts val="0"/>
+              </a:spcAft>
+              <a:buNone/>
+            </a:pPr>
+            <a:r>
+              <a:rPr sz="1050">
                 <a:solidFill>
                   <a:srgbClr val="53697C"/>
                 </a:solidFill>
                 <a:latin typeface="Noto Sans CJK SC"/>
               </a:rPr>
-              <a:t>更新 G / Π；比较 validation samples；保留合格候选。</a:t>
-            </a:r>
-          </a:p>
-        </p:txBody>
-      </p:sp>
-      <p:sp>
-        <p:nvSpPr>
-          <p:cNvPr id="30" name="h2p-13-text-29"/>
-          <p:cNvSpPr txBox="1"/>
-          <p:nvPr/>
-        </p:nvSpPr>
-        <p:spPr>
-          <a:xfrm>
-            <a:off x="9163202" y="4762195"/>
+              <a:t>更新 G / Π / ρ；比较 validation samples；保留合格候选。</a:t>
+            </a:r>
+          </a:p>
+        </p:txBody>
+      </p:sp>
+      <p:sp>
+        <p:nvSpPr>
+          <p:cNvPr id="55" name="h2p-13-text-54"/>
+          <p:cNvSpPr txBox="1"/>
+          <p:nvPr/>
+        </p:nvSpPr>
+        <p:spPr>
+          <a:xfrm>
+            <a:off x="9163202" y="6077102"/>
             <a:ext cx="2195474" cy="156362"/>
           </a:xfrm>
           <a:prstGeom prst="rect">
@@ -9882,14 +11045,14 @@
       </p:sp>
       <p:sp>
         <p:nvSpPr>
-          <p:cNvPr id="31" name="h2p-13-box-30"/>
+          <p:cNvPr id="56" name="h2p-13-box-55"/>
           <p:cNvSpPr/>
           <p:nvPr/>
         </p:nvSpPr>
         <p:spPr>
           <a:xfrm>
             <a:off x="685800" y="5352897"/>
-            <a:ext cx="10820095" cy="1123797"/>
+            <a:ext cx="5333695" cy="1123797"/>
           </a:xfrm>
           <a:prstGeom prst="roundRect">
             <a:avLst>
@@ -9930,14 +11093,14 @@
       </p:sp>
       <p:sp>
         <p:nvSpPr>
-          <p:cNvPr id="32" name="h2p-13-text-31"/>
+          <p:cNvPr id="57" name="h2p-13-text-56"/>
           <p:cNvSpPr txBox="1"/>
           <p:nvPr/>
         </p:nvSpPr>
         <p:spPr>
           <a:xfrm>
             <a:off x="914400" y="5486400"/>
-            <a:ext cx="5829300" cy="160020"/>
+            <a:ext cx="5052060" cy="160020"/>
           </a:xfrm>
           <a:prstGeom prst="rect">
             <a:avLst/>
@@ -9976,29 +11139,75 @@
       </p:sp>
       <p:sp>
         <p:nvSpPr>
-          <p:cNvPr id="33" name="h2p-13-text-32"/>
-          <p:cNvSpPr txBox="1"/>
-          <p:nvPr/>
-        </p:nvSpPr>
-        <p:spPr>
-          <a:xfrm>
-            <a:off x="914400" y="5753404"/>
-            <a:ext cx="10589666" cy="179222"/>
-          </a:xfrm>
-          <a:prstGeom prst="rect">
-            <a:avLst/>
-          </a:prstGeom>
-          <a:noFill/>
-        </p:spPr>
-        <p:txBody>
-          <a:bodyPr wrap="square" lIns="0" tIns="0" rIns="0" bIns="0">
-            <a:spAutoFit/>
-          </a:bodyPr>
-          <a:lstStyle/>
-          <a:p>
-            <a:pPr marL="0" indent="0" algn="l">
-              <a:lnSpc>
-                <a:spcPts val="1410"/>
+          <p:cNvPr id="58" name="h2p-13-text-57"/>
+          <p:cNvSpPr txBox="1"/>
+          <p:nvPr/>
+        </p:nvSpPr>
+        <p:spPr>
+          <a:xfrm>
+            <a:off x="914400" y="5734202"/>
+            <a:ext cx="5052060" cy="180136"/>
+          </a:xfrm>
+          <a:prstGeom prst="rect">
+            <a:avLst/>
+          </a:prstGeom>
+          <a:noFill/>
+        </p:spPr>
+        <p:txBody>
+          <a:bodyPr wrap="square" lIns="0" tIns="0" rIns="0" bIns="0">
+            <a:spAutoFit/>
+          </a:bodyPr>
+          <a:lstStyle/>
+          <a:p>
+            <a:pPr marL="0" indent="0" algn="l">
+              <a:lnSpc>
+                <a:spcPts val="1420"/>
+              </a:lnSpc>
+              <a:spcBef>
+                <a:spcPts val="0"/>
+              </a:spcBef>
+              <a:spcAft>
+                <a:spcPts val="0"/>
+              </a:spcAft>
+              <a:buNone/>
+            </a:pPr>
+            <a:r>
+              <a:rPr sz="1050">
+                <a:solidFill>
+                  <a:srgbClr val="53697C"/>
+                </a:solidFill>
+                <a:latin typeface="Noto Sans CJK SC"/>
+              </a:rPr>
+              <a:t>多项目轨迹更新先验，并在未见项目上稳定改善，才构成 Meta-learning 证据。</a:t>
+            </a:r>
+          </a:p>
+        </p:txBody>
+      </p:sp>
+      <p:sp>
+        <p:nvSpPr>
+          <p:cNvPr id="59" name="h2p-13-text-58"/>
+          <p:cNvSpPr txBox="1"/>
+          <p:nvPr/>
+        </p:nvSpPr>
+        <p:spPr>
+          <a:xfrm>
+            <a:off x="914400" y="6096304"/>
+            <a:ext cx="5052060" cy="321868"/>
+          </a:xfrm>
+          <a:prstGeom prst="rect">
+            <a:avLst/>
+          </a:prstGeom>
+          <a:noFill/>
+        </p:spPr>
+        <p:txBody>
+          <a:bodyPr wrap="square" lIns="0" tIns="0" rIns="0" bIns="0">
+            <a:spAutoFit/>
+          </a:bodyPr>
+          <a:lstStyle/>
+          <a:p>
+            <a:pPr marL="0" indent="0" algn="l">
+              <a:lnSpc>
+                <a:spcPts val="1270"/>
               </a:lnSpc>
               <a:spcBef>
                 <a:spcPts val="0"/>
@@ -10011,64 +11220,18 @@
             <a:r>
               <a:rPr sz="980">
                 <a:solidFill>
-                  <a:srgbClr val="53697C"/>
+                  <a:srgbClr val="718190"/>
                 </a:solidFill>
                 <a:latin typeface="Noto Sans CJK SC"/>
               </a:rPr>
-              <a:t>项目内参数优化与架构搜索不等于 Meta-learning；只有多个项目轨迹更新先验、并在未见项目上稳定改善，才构成 Meta-learning 证据。</a:t>
-            </a:r>
-          </a:p>
-        </p:txBody>
-      </p:sp>
-      <p:sp>
-        <p:nvSpPr>
-          <p:cNvPr id="34" name="h2p-13-text-33"/>
-          <p:cNvSpPr txBox="1"/>
-          <p:nvPr/>
-        </p:nvSpPr>
-        <p:spPr>
-          <a:xfrm>
-            <a:off x="914400" y="6191402"/>
-            <a:ext cx="10589666" cy="146304"/>
-          </a:xfrm>
-          <a:prstGeom prst="rect">
-            <a:avLst/>
-          </a:prstGeom>
-          <a:noFill/>
-        </p:spPr>
-        <p:txBody>
-          <a:bodyPr wrap="square" lIns="0" tIns="0" rIns="0" bIns="0">
-            <a:spAutoFit/>
-          </a:bodyPr>
-          <a:lstStyle/>
-          <a:p>
-            <a:pPr marL="0" indent="0" algn="l">
-              <a:lnSpc>
-                <a:spcPts val="1150"/>
-              </a:lnSpc>
-              <a:spcBef>
-                <a:spcPts val="0"/>
-              </a:spcBef>
-              <a:spcAft>
-                <a:spcPts val="0"/>
-              </a:spcAft>
-              <a:buNone/>
-            </a:pPr>
-            <a:r>
-              <a:rPr sz="900">
-                <a:solidFill>
-                  <a:srgbClr val="718190"/>
-                </a:solidFill>
-                <a:latin typeface="Noto Sans CJK SC"/>
-              </a:rPr>
-              <a:t>机器可执行 Schema、自动候选搜索与跨项目 Meta-learning 当前均未实现；设计契约，非运行证据。</a:t>
-            </a:r>
-          </a:p>
-        </p:txBody>
-      </p:sp>
-      <p:sp>
-        <p:nvSpPr>
-          <p:cNvPr id="35" name="h2p-13-text-34"/>
+              <a:t>Schema、自动候选搜索、跨项目 Meta-learning 均未实现；此处为设计契约，非运行证据。</a:t>
+            </a:r>
+          </a:p>
+        </p:txBody>
+      </p:sp>
+      <p:sp>
+        <p:nvSpPr>
+          <p:cNvPr id="60" name="h2p-13-text-59"/>
           <p:cNvSpPr txBox="1"/>
           <p:nvPr/>
         </p:nvSpPr>
@@ -10114,7 +11277,7 @@
       </p:sp>
       <p:sp>
         <p:nvSpPr>
-          <p:cNvPr id="36" name="h2p-13-text-35"/>
+          <p:cNvPr id="61" name="h2p-13-text-60"/>
           <p:cNvSpPr txBox="1"/>
           <p:nvPr/>
         </p:nvSpPr>
@@ -14719,7 +15882,7 @@
         <p:spPr>
           <a:xfrm>
             <a:off x="914400" y="3829507"/>
-            <a:ext cx="1972360" cy="160020"/>
+            <a:ext cx="6742785" cy="160020"/>
           </a:xfrm>
           <a:prstGeom prst="rect">
             <a:avLst/>
@@ -14758,49 +15921,70 @@
       </p:sp>
       <p:sp>
         <p:nvSpPr>
-          <p:cNvPr id="24" name="h2p-16-box-23"/>
-          <p:cNvSpPr/>
-          <p:nvPr/>
-        </p:nvSpPr>
-        <p:spPr>
-          <a:xfrm>
-            <a:off x="914400" y="4171492"/>
-            <a:ext cx="2076602" cy="323697"/>
-          </a:xfrm>
-          <a:prstGeom prst="roundRect">
-            <a:avLst>
-              <a:gd name="adj" fmla="val 23530"/>
-            </a:avLst>
-          </a:prstGeom>
-          <a:solidFill>
-            <a:srgbClr val="FFFFFF"/>
-          </a:solidFill>
-          <a:ln w="10160">
-            <a:solidFill>
-              <a:srgbClr val="53697C"/>
-            </a:solidFill>
-          </a:ln>
-          <a:effectLst/>
-        </p:spPr>
-        <p:style>
-          <a:lnRef idx="1">
-            <a:schemeClr val="accent1"/>
-          </a:lnRef>
-          <a:fillRef idx="3">
-            <a:schemeClr val="accent1"/>
-          </a:fillRef>
-          <a:effectRef idx="0">
-            <a:schemeClr val="accent1"/>
-          </a:effectRef>
-          <a:fontRef idx="minor">
-            <a:schemeClr val="lt1"/>
-          </a:fontRef>
-        </p:style>
-        <p:txBody>
-          <a:bodyPr rtlCol="0" anchor="ctr"/>
-          <a:lstStyle/>
-          <a:p>
-            <a:pPr algn="ctr"/>
+          <p:cNvPr id="24" name="h2p-16-text-23"/>
+          <p:cNvSpPr txBox="1"/>
+          <p:nvPr/>
+        </p:nvSpPr>
+        <p:spPr>
+          <a:xfrm>
+            <a:off x="914400" y="4153204"/>
+            <a:ext cx="6742785" cy="400507"/>
+          </a:xfrm>
+          <a:prstGeom prst="rect">
+            <a:avLst/>
+          </a:prstGeom>
+          <a:noFill/>
+        </p:spPr>
+        <p:txBody>
+          <a:bodyPr wrap="square" lIns="0" tIns="0" rIns="0" bIns="0">
+            <a:spAutoFit/>
+          </a:bodyPr>
+          <a:lstStyle/>
+          <a:p>
+            <a:pPr marL="0" indent="0" algn="l">
+              <a:lnSpc>
+                <a:spcPts val="1580"/>
+              </a:lnSpc>
+              <a:spcBef>
+                <a:spcPts val="0"/>
+              </a:spcBef>
+              <a:spcAft>
+                <a:spcPts val="0"/>
+              </a:spcAft>
+              <a:buNone/>
+            </a:pPr>
+            <a:r>
+              <a:rPr sz="1050">
+                <a:solidFill>
+                  <a:srgbClr val="53697C"/>
+                </a:solidFill>
+                <a:latin typeface="Noto Sans CJK SC"/>
+              </a:rPr>
+              <a:t>六类异常进入同一 Trace 语义：Agent 不可用 · Schema 非法 · 预算耗尽</a:t>
+            </a:r>
+          </a:p>
+          <a:p>
+            <a:pPr marL="0" indent="0" algn="l">
+              <a:lnSpc>
+                <a:spcPts val="1580"/>
+              </a:lnSpc>
+              <a:spcBef>
+                <a:spcPts val="0"/>
+              </a:spcBef>
+              <a:spcAft>
+                <a:spcPts val="0"/>
+              </a:spcAft>
+              <a:buNone/>
+            </a:pPr>
+            <a:r>
+              <a:rPr sz="1050">
+                <a:solidFill>
+                  <a:srgbClr val="53697C"/>
+                </a:solidFill>
+                <a:latin typeface="Noto Sans CJK SC"/>
+              </a:rPr>
+              <a:t>通信异常 · holdout 泄漏 · 循环失控。</a:t>
+            </a:r>
           </a:p>
         </p:txBody>
       </p:sp>
@@ -14812,89 +15996,110 @@
         </p:nvSpPr>
         <p:spPr>
           <a:xfrm>
-            <a:off x="1000353" y="4219956"/>
-            <a:ext cx="1943100" cy="137160"/>
-          </a:xfrm>
-          <a:prstGeom prst="rect">
-            <a:avLst/>
-          </a:prstGeom>
-          <a:noFill/>
-        </p:spPr>
-        <p:txBody>
-          <a:bodyPr wrap="square" lIns="0" tIns="0" rIns="0" bIns="0">
-            <a:spAutoFit/>
-          </a:bodyPr>
-          <a:lstStyle/>
-          <a:p>
-            <a:pPr marL="0" indent="0" algn="l">
-              <a:lnSpc>
-                <a:spcPts val="1080"/>
-              </a:lnSpc>
-              <a:spcBef>
-                <a:spcPts val="0"/>
-              </a:spcBef>
-              <a:spcAft>
-                <a:spcPts val="0"/>
-              </a:spcAft>
-              <a:buNone/>
-            </a:pPr>
-            <a:r>
-              <a:rPr b="1" sz="900">
+            <a:off x="914400" y="4762195"/>
+            <a:ext cx="6742785" cy="400507"/>
+          </a:xfrm>
+          <a:prstGeom prst="rect">
+            <a:avLst/>
+          </a:prstGeom>
+          <a:noFill/>
+        </p:spPr>
+        <p:txBody>
+          <a:bodyPr wrap="square" lIns="0" tIns="0" rIns="0" bIns="0">
+            <a:spAutoFit/>
+          </a:bodyPr>
+          <a:lstStyle/>
+          <a:p>
+            <a:pPr marL="0" indent="0" algn="l">
+              <a:lnSpc>
+                <a:spcPts val="1580"/>
+              </a:lnSpc>
+              <a:spcBef>
+                <a:spcPts val="0"/>
+              </a:spcBef>
+              <a:spcAft>
+                <a:spcPts val="0"/>
+              </a:spcAft>
+              <a:buNone/>
+            </a:pPr>
+            <a:r>
+              <a:rPr sz="1050">
                 <a:solidFill>
                   <a:srgbClr val="53697C"/>
                 </a:solidFill>
-                <a:latin typeface="Noto Sans Mono CJK SC"/>
-              </a:rPr>
-              <a:t>Agent 不可用→阶段暂停</a:t>
-            </a:r>
-          </a:p>
-        </p:txBody>
-      </p:sp>
-      <p:sp>
-        <p:nvSpPr>
-          <p:cNvPr id="26" name="h2p-16-box-25"/>
-          <p:cNvSpPr/>
-          <p:nvPr/>
-        </p:nvSpPr>
-        <p:spPr>
-          <a:xfrm>
-            <a:off x="3086100" y="4171492"/>
-            <a:ext cx="2076602" cy="323697"/>
-          </a:xfrm>
-          <a:prstGeom prst="roundRect">
-            <a:avLst>
-              <a:gd name="adj" fmla="val 23530"/>
-            </a:avLst>
-          </a:prstGeom>
-          <a:solidFill>
-            <a:srgbClr val="FFFFFF"/>
-          </a:solidFill>
-          <a:ln w="10160">
-            <a:solidFill>
-              <a:srgbClr val="53697C"/>
-            </a:solidFill>
-          </a:ln>
-          <a:effectLst/>
-        </p:spPr>
-        <p:style>
-          <a:lnRef idx="1">
-            <a:schemeClr val="accent1"/>
-          </a:lnRef>
-          <a:fillRef idx="3">
-            <a:schemeClr val="accent1"/>
-          </a:fillRef>
-          <a:effectRef idx="0">
-            <a:schemeClr val="accent1"/>
-          </a:effectRef>
-          <a:fontRef idx="minor">
-            <a:schemeClr val="lt1"/>
-          </a:fontRef>
-        </p:style>
-        <p:txBody>
-          <a:bodyPr rtlCol="0" anchor="ctr"/>
-          <a:lstStyle/>
-          <a:p>
-            <a:pPr algn="ctr"/>
+                <a:latin typeface="Noto Sans CJK SC"/>
+              </a:rPr>
+              <a:t>对应恢复：阶段暂停 · 拒绝推进 · 硬停止</a:t>
+            </a:r>
+          </a:p>
+          <a:p>
+            <a:pPr marL="0" indent="0" algn="l">
+              <a:lnSpc>
+                <a:spcPts val="1580"/>
+              </a:lnSpc>
+              <a:spcBef>
+                <a:spcPts val="0"/>
+              </a:spcBef>
+              <a:spcAft>
+                <a:spcPts val="0"/>
+              </a:spcAft>
+              <a:buNone/>
+            </a:pPr>
+            <a:r>
+              <a:rPr sz="1050">
+                <a:solidFill>
+                  <a:srgbClr val="53697C"/>
+                </a:solidFill>
+                <a:latin typeface="Noto Sans CJK SC"/>
+              </a:rPr>
+              <a:t>幂等重发 · 本轮无效 · 达上限停止。</a:t>
+            </a:r>
+          </a:p>
+        </p:txBody>
+      </p:sp>
+      <p:sp>
+        <p:nvSpPr>
+          <p:cNvPr id="26" name="h2p-16-text-25"/>
+          <p:cNvSpPr txBox="1"/>
+          <p:nvPr/>
+        </p:nvSpPr>
+        <p:spPr>
+          <a:xfrm>
+            <a:off x="914400" y="5372100"/>
+            <a:ext cx="6742785" cy="185623"/>
+          </a:xfrm>
+          <a:prstGeom prst="rect">
+            <a:avLst/>
+          </a:prstGeom>
+          <a:noFill/>
+        </p:spPr>
+        <p:txBody>
+          <a:bodyPr wrap="square" lIns="0" tIns="0" rIns="0" bIns="0">
+            <a:spAutoFit/>
+          </a:bodyPr>
+          <a:lstStyle/>
+          <a:p>
+            <a:pPr marL="0" indent="0" algn="l">
+              <a:lnSpc>
+                <a:spcPts val="1460"/>
+              </a:lnSpc>
+              <a:spcBef>
+                <a:spcPts val="0"/>
+              </a:spcBef>
+              <a:spcAft>
+                <a:spcPts val="0"/>
+              </a:spcAft>
+              <a:buNone/>
+            </a:pPr>
+            <a:r>
+              <a:rPr sz="980">
+                <a:solidFill>
+                  <a:srgbClr val="53697C"/>
+                </a:solidFill>
+                <a:latin typeface="Noto Sans CJK SC"/>
+              </a:rPr>
+              <a:t>权限缺失→缩小范围;不可回滚→默认拒绝;成功与失败同等留证。</a:t>
+            </a:r>
           </a:p>
         </p:txBody>
       </p:sp>
@@ -14906,40 +16111,40 @@
         </p:nvSpPr>
         <p:spPr>
           <a:xfrm>
-            <a:off x="3172053" y="4219956"/>
-            <a:ext cx="1943100" cy="137160"/>
-          </a:xfrm>
-          <a:prstGeom prst="rect">
-            <a:avLst/>
-          </a:prstGeom>
-          <a:noFill/>
-        </p:spPr>
-        <p:txBody>
-          <a:bodyPr wrap="square" lIns="0" tIns="0" rIns="0" bIns="0">
-            <a:spAutoFit/>
-          </a:bodyPr>
-          <a:lstStyle/>
-          <a:p>
-            <a:pPr marL="0" indent="0" algn="l">
-              <a:lnSpc>
-                <a:spcPts val="1080"/>
-              </a:lnSpc>
-              <a:spcBef>
-                <a:spcPts val="0"/>
-              </a:spcBef>
-              <a:spcAft>
-                <a:spcPts val="0"/>
-              </a:spcAft>
-              <a:buNone/>
-            </a:pPr>
-            <a:r>
-              <a:rPr b="1" sz="900">
-                <a:solidFill>
-                  <a:srgbClr val="53697C"/>
-                </a:solidFill>
-                <a:latin typeface="Noto Sans Mono CJK SC"/>
-              </a:rPr>
-              <a:t>Schema 非法→拒绝推进</a:t>
+            <a:off x="914400" y="5753404"/>
+            <a:ext cx="6742785" cy="156362"/>
+          </a:xfrm>
+          <a:prstGeom prst="rect">
+            <a:avLst/>
+          </a:prstGeom>
+          <a:noFill/>
+        </p:spPr>
+        <p:txBody>
+          <a:bodyPr wrap="square" lIns="0" tIns="0" rIns="0" bIns="0">
+            <a:spAutoFit/>
+          </a:bodyPr>
+          <a:lstStyle/>
+          <a:p>
+            <a:pPr marL="0" indent="0" algn="l">
+              <a:lnSpc>
+                <a:spcPts val="1230"/>
+              </a:lnSpc>
+              <a:spcBef>
+                <a:spcPts val="0"/>
+              </a:spcBef>
+              <a:spcAft>
+                <a:spcPts val="0"/>
+              </a:spcAft>
+              <a:buNone/>
+            </a:pPr>
+            <a:r>
+              <a:rPr b="1" sz="980">
+                <a:solidFill>
+                  <a:srgbClr val="F26B4B"/>
+                </a:solidFill>
+                <a:latin typeface="Noto Sans CJK SC"/>
+              </a:rPr>
+              <a:t>候选生成前冻结 Sample/Task · 候选生成后统一试验前批准 TrialSpec</a:t>
             </a:r>
           </a:p>
         </p:txBody>
@@ -14947,474 +16152,6 @@
       <p:sp>
         <p:nvSpPr>
           <p:cNvPr id="28" name="h2p-16-box-27"/>
-          <p:cNvSpPr/>
-          <p:nvPr/>
-        </p:nvSpPr>
-        <p:spPr>
-          <a:xfrm>
-            <a:off x="5257800" y="4171492"/>
-            <a:ext cx="2286000" cy="323697"/>
-          </a:xfrm>
-          <a:prstGeom prst="roundRect">
-            <a:avLst>
-              <a:gd name="adj" fmla="val 23530"/>
-            </a:avLst>
-          </a:prstGeom>
-          <a:solidFill>
-            <a:srgbClr val="FFFFFF"/>
-          </a:solidFill>
-          <a:ln w="10160">
-            <a:solidFill>
-              <a:srgbClr val="53697C"/>
-            </a:solidFill>
-          </a:ln>
-          <a:effectLst/>
-        </p:spPr>
-        <p:style>
-          <a:lnRef idx="1">
-            <a:schemeClr val="accent1"/>
-          </a:lnRef>
-          <a:fillRef idx="3">
-            <a:schemeClr val="accent1"/>
-          </a:fillRef>
-          <a:effectRef idx="0">
-            <a:schemeClr val="accent1"/>
-          </a:effectRef>
-          <a:fontRef idx="minor">
-            <a:schemeClr val="lt1"/>
-          </a:fontRef>
-        </p:style>
-        <p:txBody>
-          <a:bodyPr rtlCol="0" anchor="ctr"/>
-          <a:lstStyle/>
-          <a:p>
-            <a:pPr algn="ctr"/>
-          </a:p>
-        </p:txBody>
-      </p:sp>
-      <p:sp>
-        <p:nvSpPr>
-          <p:cNvPr id="29" name="h2p-16-text-28"/>
-          <p:cNvSpPr txBox="1"/>
-          <p:nvPr/>
-        </p:nvSpPr>
-        <p:spPr>
-          <a:xfrm>
-            <a:off x="5343753" y="4219956"/>
-            <a:ext cx="2157069" cy="137160"/>
-          </a:xfrm>
-          <a:prstGeom prst="rect">
-            <a:avLst/>
-          </a:prstGeom>
-          <a:noFill/>
-        </p:spPr>
-        <p:txBody>
-          <a:bodyPr wrap="square" lIns="0" tIns="0" rIns="0" bIns="0">
-            <a:spAutoFit/>
-          </a:bodyPr>
-          <a:lstStyle/>
-          <a:p>
-            <a:pPr marL="0" indent="0" algn="l">
-              <a:lnSpc>
-                <a:spcPts val="1080"/>
-              </a:lnSpc>
-              <a:spcBef>
-                <a:spcPts val="0"/>
-              </a:spcBef>
-              <a:spcAft>
-                <a:spcPts val="0"/>
-              </a:spcAft>
-              <a:buNone/>
-            </a:pPr>
-            <a:r>
-              <a:rPr b="1" sz="900">
-                <a:solidFill>
-                  <a:srgbClr val="53697C"/>
-                </a:solidFill>
-                <a:latin typeface="Noto Sans Mono CJK SC"/>
-              </a:rPr>
-              <a:t>预算耗尽→硬停止</a:t>
-            </a:r>
-          </a:p>
-        </p:txBody>
-      </p:sp>
-      <p:sp>
-        <p:nvSpPr>
-          <p:cNvPr id="30" name="h2p-16-box-29"/>
-          <p:cNvSpPr/>
-          <p:nvPr/>
-        </p:nvSpPr>
-        <p:spPr>
-          <a:xfrm>
-            <a:off x="914400" y="4628692"/>
-            <a:ext cx="2076602" cy="323697"/>
-          </a:xfrm>
-          <a:prstGeom prst="roundRect">
-            <a:avLst>
-              <a:gd name="adj" fmla="val 23530"/>
-            </a:avLst>
-          </a:prstGeom>
-          <a:solidFill>
-            <a:srgbClr val="FFFFFF"/>
-          </a:solidFill>
-          <a:ln w="10160">
-            <a:solidFill>
-              <a:srgbClr val="53697C"/>
-            </a:solidFill>
-          </a:ln>
-          <a:effectLst/>
-        </p:spPr>
-        <p:style>
-          <a:lnRef idx="1">
-            <a:schemeClr val="accent1"/>
-          </a:lnRef>
-          <a:fillRef idx="3">
-            <a:schemeClr val="accent1"/>
-          </a:fillRef>
-          <a:effectRef idx="0">
-            <a:schemeClr val="accent1"/>
-          </a:effectRef>
-          <a:fontRef idx="minor">
-            <a:schemeClr val="lt1"/>
-          </a:fontRef>
-        </p:style>
-        <p:txBody>
-          <a:bodyPr rtlCol="0" anchor="ctr"/>
-          <a:lstStyle/>
-          <a:p>
-            <a:pPr algn="ctr"/>
-          </a:p>
-        </p:txBody>
-      </p:sp>
-      <p:sp>
-        <p:nvSpPr>
-          <p:cNvPr id="31" name="h2p-16-text-30"/>
-          <p:cNvSpPr txBox="1"/>
-          <p:nvPr/>
-        </p:nvSpPr>
-        <p:spPr>
-          <a:xfrm>
-            <a:off x="1000353" y="4677156"/>
-            <a:ext cx="1943100" cy="137160"/>
-          </a:xfrm>
-          <a:prstGeom prst="rect">
-            <a:avLst/>
-          </a:prstGeom>
-          <a:noFill/>
-        </p:spPr>
-        <p:txBody>
-          <a:bodyPr wrap="square" lIns="0" tIns="0" rIns="0" bIns="0">
-            <a:spAutoFit/>
-          </a:bodyPr>
-          <a:lstStyle/>
-          <a:p>
-            <a:pPr marL="0" indent="0" algn="l">
-              <a:lnSpc>
-                <a:spcPts val="1080"/>
-              </a:lnSpc>
-              <a:spcBef>
-                <a:spcPts val="0"/>
-              </a:spcBef>
-              <a:spcAft>
-                <a:spcPts val="0"/>
-              </a:spcAft>
-              <a:buNone/>
-            </a:pPr>
-            <a:r>
-              <a:rPr b="1" sz="900">
-                <a:solidFill>
-                  <a:srgbClr val="53697C"/>
-                </a:solidFill>
-                <a:latin typeface="Noto Sans Mono CJK SC"/>
-              </a:rPr>
-              <a:t>通信异常→幂等重发</a:t>
-            </a:r>
-          </a:p>
-        </p:txBody>
-      </p:sp>
-      <p:sp>
-        <p:nvSpPr>
-          <p:cNvPr id="32" name="h2p-16-box-31"/>
-          <p:cNvSpPr/>
-          <p:nvPr/>
-        </p:nvSpPr>
-        <p:spPr>
-          <a:xfrm>
-            <a:off x="3086100" y="4628692"/>
-            <a:ext cx="2076602" cy="323697"/>
-          </a:xfrm>
-          <a:prstGeom prst="roundRect">
-            <a:avLst>
-              <a:gd name="adj" fmla="val 23530"/>
-            </a:avLst>
-          </a:prstGeom>
-          <a:solidFill>
-            <a:srgbClr val="FFFFFF"/>
-          </a:solidFill>
-          <a:ln w="10160">
-            <a:solidFill>
-              <a:srgbClr val="53697C"/>
-            </a:solidFill>
-          </a:ln>
-          <a:effectLst/>
-        </p:spPr>
-        <p:style>
-          <a:lnRef idx="1">
-            <a:schemeClr val="accent1"/>
-          </a:lnRef>
-          <a:fillRef idx="3">
-            <a:schemeClr val="accent1"/>
-          </a:fillRef>
-          <a:effectRef idx="0">
-            <a:schemeClr val="accent1"/>
-          </a:effectRef>
-          <a:fontRef idx="minor">
-            <a:schemeClr val="lt1"/>
-          </a:fontRef>
-        </p:style>
-        <p:txBody>
-          <a:bodyPr rtlCol="0" anchor="ctr"/>
-          <a:lstStyle/>
-          <a:p>
-            <a:pPr algn="ctr"/>
-          </a:p>
-        </p:txBody>
-      </p:sp>
-      <p:sp>
-        <p:nvSpPr>
-          <p:cNvPr id="33" name="h2p-16-text-32"/>
-          <p:cNvSpPr txBox="1"/>
-          <p:nvPr/>
-        </p:nvSpPr>
-        <p:spPr>
-          <a:xfrm>
-            <a:off x="3172053" y="4677156"/>
-            <a:ext cx="1943100" cy="137160"/>
-          </a:xfrm>
-          <a:prstGeom prst="rect">
-            <a:avLst/>
-          </a:prstGeom>
-          <a:noFill/>
-        </p:spPr>
-        <p:txBody>
-          <a:bodyPr wrap="square" lIns="0" tIns="0" rIns="0" bIns="0">
-            <a:spAutoFit/>
-          </a:bodyPr>
-          <a:lstStyle/>
-          <a:p>
-            <a:pPr marL="0" indent="0" algn="l">
-              <a:lnSpc>
-                <a:spcPts val="1080"/>
-              </a:lnSpc>
-              <a:spcBef>
-                <a:spcPts val="0"/>
-              </a:spcBef>
-              <a:spcAft>
-                <a:spcPts val="0"/>
-              </a:spcAft>
-              <a:buNone/>
-            </a:pPr>
-            <a:r>
-              <a:rPr b="1" sz="900">
-                <a:solidFill>
-                  <a:srgbClr val="53697C"/>
-                </a:solidFill>
-                <a:latin typeface="Noto Sans Mono CJK SC"/>
-              </a:rPr>
-              <a:t>holdout 泄漏→本轮无效</a:t>
-            </a:r>
-          </a:p>
-        </p:txBody>
-      </p:sp>
-      <p:sp>
-        <p:nvSpPr>
-          <p:cNvPr id="34" name="h2p-16-box-33"/>
-          <p:cNvSpPr/>
-          <p:nvPr/>
-        </p:nvSpPr>
-        <p:spPr>
-          <a:xfrm>
-            <a:off x="5257800" y="4628692"/>
-            <a:ext cx="2286000" cy="323697"/>
-          </a:xfrm>
-          <a:prstGeom prst="roundRect">
-            <a:avLst>
-              <a:gd name="adj" fmla="val 23530"/>
-            </a:avLst>
-          </a:prstGeom>
-          <a:solidFill>
-            <a:srgbClr val="FFFFFF"/>
-          </a:solidFill>
-          <a:ln w="10160">
-            <a:solidFill>
-              <a:srgbClr val="53697C"/>
-            </a:solidFill>
-          </a:ln>
-          <a:effectLst/>
-        </p:spPr>
-        <p:style>
-          <a:lnRef idx="1">
-            <a:schemeClr val="accent1"/>
-          </a:lnRef>
-          <a:fillRef idx="3">
-            <a:schemeClr val="accent1"/>
-          </a:fillRef>
-          <a:effectRef idx="0">
-            <a:schemeClr val="accent1"/>
-          </a:effectRef>
-          <a:fontRef idx="minor">
-            <a:schemeClr val="lt1"/>
-          </a:fontRef>
-        </p:style>
-        <p:txBody>
-          <a:bodyPr rtlCol="0" anchor="ctr"/>
-          <a:lstStyle/>
-          <a:p>
-            <a:pPr algn="ctr"/>
-          </a:p>
-        </p:txBody>
-      </p:sp>
-      <p:sp>
-        <p:nvSpPr>
-          <p:cNvPr id="35" name="h2p-16-text-34"/>
-          <p:cNvSpPr txBox="1"/>
-          <p:nvPr/>
-        </p:nvSpPr>
-        <p:spPr>
-          <a:xfrm>
-            <a:off x="5343753" y="4677156"/>
-            <a:ext cx="2157069" cy="137160"/>
-          </a:xfrm>
-          <a:prstGeom prst="rect">
-            <a:avLst/>
-          </a:prstGeom>
-          <a:noFill/>
-        </p:spPr>
-        <p:txBody>
-          <a:bodyPr wrap="square" lIns="0" tIns="0" rIns="0" bIns="0">
-            <a:spAutoFit/>
-          </a:bodyPr>
-          <a:lstStyle/>
-          <a:p>
-            <a:pPr marL="0" indent="0" algn="l">
-              <a:lnSpc>
-                <a:spcPts val="1080"/>
-              </a:lnSpc>
-              <a:spcBef>
-                <a:spcPts val="0"/>
-              </a:spcBef>
-              <a:spcAft>
-                <a:spcPts val="0"/>
-              </a:spcAft>
-              <a:buNone/>
-            </a:pPr>
-            <a:r>
-              <a:rPr b="1" sz="900">
-                <a:solidFill>
-                  <a:srgbClr val="53697C"/>
-                </a:solidFill>
-                <a:latin typeface="Noto Sans Mono CJK SC"/>
-              </a:rPr>
-              <a:t>循环失控→达上限停止</a:t>
-            </a:r>
-          </a:p>
-        </p:txBody>
-      </p:sp>
-      <p:sp>
-        <p:nvSpPr>
-          <p:cNvPr id="36" name="h2p-16-text-35"/>
-          <p:cNvSpPr txBox="1"/>
-          <p:nvPr/>
-        </p:nvSpPr>
-        <p:spPr>
-          <a:xfrm>
-            <a:off x="914400" y="5162702"/>
-            <a:ext cx="6742785" cy="185623"/>
-          </a:xfrm>
-          <a:prstGeom prst="rect">
-            <a:avLst/>
-          </a:prstGeom>
-          <a:noFill/>
-        </p:spPr>
-        <p:txBody>
-          <a:bodyPr wrap="square" lIns="0" tIns="0" rIns="0" bIns="0">
-            <a:spAutoFit/>
-          </a:bodyPr>
-          <a:lstStyle/>
-          <a:p>
-            <a:pPr marL="0" indent="0" algn="l">
-              <a:lnSpc>
-                <a:spcPts val="1460"/>
-              </a:lnSpc>
-              <a:spcBef>
-                <a:spcPts val="0"/>
-              </a:spcBef>
-              <a:spcAft>
-                <a:spcPts val="0"/>
-              </a:spcAft>
-              <a:buNone/>
-            </a:pPr>
-            <a:r>
-              <a:rPr sz="980">
-                <a:solidFill>
-                  <a:srgbClr val="53697C"/>
-                </a:solidFill>
-                <a:latin typeface="Noto Sans CJK SC"/>
-              </a:rPr>
-              <a:t>权限缺失→缩小范围；不可回滚→默认拒绝；成功与失败同等留证。</a:t>
-            </a:r>
-          </a:p>
-        </p:txBody>
-      </p:sp>
-      <p:sp>
-        <p:nvSpPr>
-          <p:cNvPr id="37" name="h2p-16-text-36"/>
-          <p:cNvSpPr txBox="1"/>
-          <p:nvPr/>
-        </p:nvSpPr>
-        <p:spPr>
-          <a:xfrm>
-            <a:off x="914400" y="5639104"/>
-            <a:ext cx="6742785" cy="156362"/>
-          </a:xfrm>
-          <a:prstGeom prst="rect">
-            <a:avLst/>
-          </a:prstGeom>
-          <a:noFill/>
-        </p:spPr>
-        <p:txBody>
-          <a:bodyPr wrap="square" lIns="0" tIns="0" rIns="0" bIns="0">
-            <a:spAutoFit/>
-          </a:bodyPr>
-          <a:lstStyle/>
-          <a:p>
-            <a:pPr marL="0" indent="0" algn="l">
-              <a:lnSpc>
-                <a:spcPts val="1230"/>
-              </a:lnSpc>
-              <a:spcBef>
-                <a:spcPts val="0"/>
-              </a:spcBef>
-              <a:spcAft>
-                <a:spcPts val="0"/>
-              </a:spcAft>
-              <a:buNone/>
-            </a:pPr>
-            <a:r>
-              <a:rPr b="1" sz="980">
-                <a:solidFill>
-                  <a:srgbClr val="F26B4B"/>
-                </a:solidFill>
-                <a:latin typeface="Noto Sans CJK SC"/>
-              </a:rPr>
-              <a:t>候选生成前冻结 Sample/Task · 候选生成后统一试验前批准 TrialSpec</a:t>
-            </a:r>
-          </a:p>
-        </p:txBody>
-      </p:sp>
-      <p:sp>
-        <p:nvSpPr>
-          <p:cNvPr id="38" name="h2p-16-box-37"/>
           <p:cNvSpPr/>
           <p:nvPr/>
         </p:nvSpPr>
@@ -15462,7 +16199,7 @@
       </p:sp>
       <p:sp>
         <p:nvSpPr>
-          <p:cNvPr id="39" name="h2p-16-text-38"/>
+          <p:cNvPr id="29" name="h2p-16-text-28"/>
           <p:cNvSpPr txBox="1"/>
           <p:nvPr/>
         </p:nvSpPr>
@@ -15508,7 +16245,7 @@
       </p:sp>
       <p:sp>
         <p:nvSpPr>
-          <p:cNvPr id="40" name="h2p-16-box-39"/>
+          <p:cNvPr id="30" name="h2p-16-box-29"/>
           <p:cNvSpPr/>
           <p:nvPr/>
         </p:nvSpPr>
@@ -15556,7 +16293,7 @@
       </p:sp>
       <p:sp>
         <p:nvSpPr>
-          <p:cNvPr id="41" name="h2p-16-text-40"/>
+          <p:cNvPr id="31" name="h2p-16-text-30"/>
           <p:cNvSpPr txBox="1"/>
           <p:nvPr/>
         </p:nvSpPr>
@@ -15602,7 +16339,7 @@
       </p:sp>
       <p:sp>
         <p:nvSpPr>
-          <p:cNvPr id="42" name="h2p-16-box-41"/>
+          <p:cNvPr id="32" name="h2p-16-box-31"/>
           <p:cNvSpPr/>
           <p:nvPr/>
         </p:nvSpPr>
@@ -15650,7 +16387,7 @@
       </p:sp>
       <p:sp>
         <p:nvSpPr>
-          <p:cNvPr id="43" name="h2p-16-text-42"/>
+          <p:cNvPr id="33" name="h2p-16-text-32"/>
           <p:cNvSpPr txBox="1"/>
           <p:nvPr/>
         </p:nvSpPr>
@@ -15696,7 +16433,7 @@
       </p:sp>
       <p:sp>
         <p:nvSpPr>
-          <p:cNvPr id="44" name="h2p-16-box-43"/>
+          <p:cNvPr id="34" name="h2p-16-box-33"/>
           <p:cNvSpPr/>
           <p:nvPr/>
         </p:nvSpPr>
@@ -15744,7 +16481,7 @@
       </p:sp>
       <p:sp>
         <p:nvSpPr>
-          <p:cNvPr id="45" name="h2p-16-text-44"/>
+          <p:cNvPr id="35" name="h2p-16-text-34"/>
           <p:cNvSpPr txBox="1"/>
           <p:nvPr/>
         </p:nvSpPr>
@@ -15790,7 +16527,7 @@
       </p:sp>
       <p:sp>
         <p:nvSpPr>
-          <p:cNvPr id="46" name="h2p-16-box-45"/>
+          <p:cNvPr id="36" name="h2p-16-box-35"/>
           <p:cNvSpPr/>
           <p:nvPr/>
         </p:nvSpPr>
@@ -15838,7 +16575,7 @@
       </p:sp>
       <p:sp>
         <p:nvSpPr>
-          <p:cNvPr id="47" name="h2p-16-text-46"/>
+          <p:cNvPr id="37" name="h2p-16-text-36"/>
           <p:cNvSpPr txBox="1"/>
           <p:nvPr/>
         </p:nvSpPr>
@@ -15884,7 +16621,7 @@
       </p:sp>
       <p:sp>
         <p:nvSpPr>
-          <p:cNvPr id="48" name="h2p-16-text-47"/>
+          <p:cNvPr id="38" name="h2p-16-text-37"/>
           <p:cNvSpPr txBox="1"/>
           <p:nvPr/>
         </p:nvSpPr>
@@ -15930,7 +16667,7 @@
       </p:sp>
       <p:sp>
         <p:nvSpPr>
-          <p:cNvPr id="49" name="h2p-16-text-48"/>
+          <p:cNvPr id="39" name="h2p-16-text-38"/>
           <p:cNvSpPr txBox="1"/>
           <p:nvPr/>
         </p:nvSpPr>
@@ -15976,7 +16713,7 @@
       </p:sp>
       <p:sp>
         <p:nvSpPr>
-          <p:cNvPr id="50" name="h2p-16-text-49"/>
+          <p:cNvPr id="40" name="h2p-16-text-39"/>
           <p:cNvSpPr txBox="1"/>
           <p:nvPr/>
         </p:nvSpPr>
@@ -23897,11 +24634,11 @@
         <p:spPr>
           <a:xfrm>
             <a:off x="685800" y="2229307"/>
-            <a:ext cx="5296204" cy="3504895"/>
+            <a:ext cx="5296204" cy="2704795"/>
           </a:xfrm>
           <a:prstGeom prst="roundRect">
             <a:avLst>
-              <a:gd name="adj" fmla="val 4890"/>
+              <a:gd name="adj" fmla="val 6340"/>
             </a:avLst>
           </a:prstGeom>
           <a:solidFill>
@@ -23944,7 +24681,7 @@
         </p:nvSpPr>
         <p:spPr>
           <a:xfrm>
-            <a:off x="914400" y="2400300"/>
+            <a:off x="914400" y="2361895"/>
             <a:ext cx="2040026" cy="160020"/>
           </a:xfrm>
           <a:prstGeom prst="rect">
@@ -23990,34 +24727,34 @@
         </p:nvSpPr>
         <p:spPr>
           <a:xfrm>
-            <a:off x="914400" y="2704795"/>
-            <a:ext cx="4955133" cy="224942"/>
-          </a:xfrm>
-          <a:prstGeom prst="rect">
-            <a:avLst/>
-          </a:prstGeom>
-          <a:noFill/>
-        </p:spPr>
-        <p:txBody>
-          <a:bodyPr wrap="square" lIns="0" tIns="0" rIns="0" bIns="0">
-            <a:spAutoFit/>
-          </a:bodyPr>
-          <a:lstStyle/>
-          <a:p>
-            <a:pPr marL="0" indent="0" algn="l">
-              <a:lnSpc>
-                <a:spcPts val="1770"/>
-              </a:lnSpc>
-              <a:spcBef>
-                <a:spcPts val="0"/>
-              </a:spcBef>
-              <a:spcAft>
-                <a:spcPts val="0"/>
-              </a:spcAft>
-              <a:buNone/>
-            </a:pPr>
-            <a:r>
-              <a:rPr b="1" sz="1500">
+            <a:off x="914400" y="2628900"/>
+            <a:ext cx="4955133" cy="202082"/>
+          </a:xfrm>
+          <a:prstGeom prst="rect">
+            <a:avLst/>
+          </a:prstGeom>
+          <a:noFill/>
+        </p:spPr>
+        <p:txBody>
+          <a:bodyPr wrap="square" lIns="0" tIns="0" rIns="0" bIns="0">
+            <a:spAutoFit/>
+          </a:bodyPr>
+          <a:lstStyle/>
+          <a:p>
+            <a:pPr marL="0" indent="0" algn="l">
+              <a:lnSpc>
+                <a:spcPts val="1590"/>
+              </a:lnSpc>
+              <a:spcBef>
+                <a:spcPts val="0"/>
+              </a:spcBef>
+              <a:spcAft>
+                <a:spcPts val="0"/>
+              </a:spcAft>
+              <a:buNone/>
+            </a:pPr>
+            <a:r>
+              <a:rPr b="1" sz="1350">
                 <a:solidFill>
                   <a:srgbClr val="102A43"/>
                 </a:solidFill>
@@ -24036,34 +24773,34 @@
         </p:nvSpPr>
         <p:spPr>
           <a:xfrm>
-            <a:off x="914400" y="3010204"/>
-            <a:ext cx="4955133" cy="192938"/>
-          </a:xfrm>
-          <a:prstGeom prst="rect">
-            <a:avLst/>
-          </a:prstGeom>
-          <a:noFill/>
-        </p:spPr>
-        <p:txBody>
-          <a:bodyPr wrap="square" lIns="0" tIns="0" rIns="0" bIns="0">
-            <a:spAutoFit/>
-          </a:bodyPr>
-          <a:lstStyle/>
-          <a:p>
-            <a:pPr marL="0" indent="0" algn="l">
-              <a:lnSpc>
-                <a:spcPts val="1520"/>
-              </a:lnSpc>
-              <a:spcBef>
-                <a:spcPts val="0"/>
-              </a:spcBef>
-              <a:spcAft>
-                <a:spcPts val="0"/>
-              </a:spcAft>
-              <a:buNone/>
-            </a:pPr>
-            <a:r>
-              <a:rPr sz="1050">
+            <a:off x="914400" y="2876702"/>
+            <a:ext cx="4955133" cy="172821"/>
+          </a:xfrm>
+          <a:prstGeom prst="rect">
+            <a:avLst/>
+          </a:prstGeom>
+          <a:noFill/>
+        </p:spPr>
+        <p:txBody>
+          <a:bodyPr wrap="square" lIns="0" tIns="0" rIns="0" bIns="0">
+            <a:spAutoFit/>
+          </a:bodyPr>
+          <a:lstStyle/>
+          <a:p>
+            <a:pPr marL="0" indent="0" algn="l">
+              <a:lnSpc>
+                <a:spcPts val="1360"/>
+              </a:lnSpc>
+              <a:spcBef>
+                <a:spcPts val="0"/>
+              </a:spcBef>
+              <a:spcAft>
+                <a:spcPts val="0"/>
+              </a:spcAft>
+              <a:buNone/>
+            </a:pPr>
+            <a:r>
+              <a:rPr sz="980">
                 <a:solidFill>
                   <a:srgbClr val="53697C"/>
                 </a:solidFill>
@@ -24082,34 +24819,34 @@
         </p:nvSpPr>
         <p:spPr>
           <a:xfrm>
-            <a:off x="914400" y="3429000"/>
-            <a:ext cx="4955133" cy="224942"/>
-          </a:xfrm>
-          <a:prstGeom prst="rect">
-            <a:avLst/>
-          </a:prstGeom>
-          <a:noFill/>
-        </p:spPr>
-        <p:txBody>
-          <a:bodyPr wrap="square" lIns="0" tIns="0" rIns="0" bIns="0">
-            <a:spAutoFit/>
-          </a:bodyPr>
-          <a:lstStyle/>
-          <a:p>
-            <a:pPr marL="0" indent="0" algn="l">
-              <a:lnSpc>
-                <a:spcPts val="1770"/>
-              </a:lnSpc>
-              <a:spcBef>
-                <a:spcPts val="0"/>
-              </a:spcBef>
-              <a:spcAft>
-                <a:spcPts val="0"/>
-              </a:spcAft>
-              <a:buNone/>
-            </a:pPr>
-            <a:r>
-              <a:rPr b="1" sz="1500">
+            <a:off x="914400" y="3238804"/>
+            <a:ext cx="4955133" cy="202082"/>
+          </a:xfrm>
+          <a:prstGeom prst="rect">
+            <a:avLst/>
+          </a:prstGeom>
+          <a:noFill/>
+        </p:spPr>
+        <p:txBody>
+          <a:bodyPr wrap="square" lIns="0" tIns="0" rIns="0" bIns="0">
+            <a:spAutoFit/>
+          </a:bodyPr>
+          <a:lstStyle/>
+          <a:p>
+            <a:pPr marL="0" indent="0" algn="l">
+              <a:lnSpc>
+                <a:spcPts val="1590"/>
+              </a:lnSpc>
+              <a:spcBef>
+                <a:spcPts val="0"/>
+              </a:spcBef>
+              <a:spcAft>
+                <a:spcPts val="0"/>
+              </a:spcAft>
+              <a:buNone/>
+            </a:pPr>
+            <a:r>
+              <a:rPr b="1" sz="1350">
                 <a:solidFill>
                   <a:srgbClr val="102A43"/>
                 </a:solidFill>
@@ -24128,34 +24865,34 @@
         </p:nvSpPr>
         <p:spPr>
           <a:xfrm>
-            <a:off x="914400" y="3733495"/>
-            <a:ext cx="4955133" cy="192938"/>
-          </a:xfrm>
-          <a:prstGeom prst="rect">
-            <a:avLst/>
-          </a:prstGeom>
-          <a:noFill/>
-        </p:spPr>
-        <p:txBody>
-          <a:bodyPr wrap="square" lIns="0" tIns="0" rIns="0" bIns="0">
-            <a:spAutoFit/>
-          </a:bodyPr>
-          <a:lstStyle/>
-          <a:p>
-            <a:pPr marL="0" indent="0" algn="l">
-              <a:lnSpc>
-                <a:spcPts val="1520"/>
-              </a:lnSpc>
-              <a:spcBef>
-                <a:spcPts val="0"/>
-              </a:spcBef>
-              <a:spcAft>
-                <a:spcPts val="0"/>
-              </a:spcAft>
-              <a:buNone/>
-            </a:pPr>
-            <a:r>
-              <a:rPr sz="1050">
+            <a:off x="914400" y="3485692"/>
+            <a:ext cx="4955133" cy="172821"/>
+          </a:xfrm>
+          <a:prstGeom prst="rect">
+            <a:avLst/>
+          </a:prstGeom>
+          <a:noFill/>
+        </p:spPr>
+        <p:txBody>
+          <a:bodyPr wrap="square" lIns="0" tIns="0" rIns="0" bIns="0">
+            <a:spAutoFit/>
+          </a:bodyPr>
+          <a:lstStyle/>
+          <a:p>
+            <a:pPr marL="0" indent="0" algn="l">
+              <a:lnSpc>
+                <a:spcPts val="1360"/>
+              </a:lnSpc>
+              <a:spcBef>
+                <a:spcPts val="0"/>
+              </a:spcBef>
+              <a:spcAft>
+                <a:spcPts val="0"/>
+              </a:spcAft>
+              <a:buNone/>
+            </a:pPr>
+            <a:r>
+              <a:rPr sz="980">
                 <a:solidFill>
                   <a:srgbClr val="53697C"/>
                 </a:solidFill>
@@ -24174,34 +24911,34 @@
         </p:nvSpPr>
         <p:spPr>
           <a:xfrm>
-            <a:off x="914400" y="4153204"/>
-            <a:ext cx="4955133" cy="224942"/>
-          </a:xfrm>
-          <a:prstGeom prst="rect">
-            <a:avLst/>
-          </a:prstGeom>
-          <a:noFill/>
-        </p:spPr>
-        <p:txBody>
-          <a:bodyPr wrap="square" lIns="0" tIns="0" rIns="0" bIns="0">
-            <a:spAutoFit/>
-          </a:bodyPr>
-          <a:lstStyle/>
-          <a:p>
-            <a:pPr marL="0" indent="0" algn="l">
-              <a:lnSpc>
-                <a:spcPts val="1770"/>
-              </a:lnSpc>
-              <a:spcBef>
-                <a:spcPts val="0"/>
-              </a:spcBef>
-              <a:spcAft>
-                <a:spcPts val="0"/>
-              </a:spcAft>
-              <a:buNone/>
-            </a:pPr>
-            <a:r>
-              <a:rPr b="1" sz="1500">
+            <a:off x="914400" y="3847795"/>
+            <a:ext cx="4955133" cy="202082"/>
+          </a:xfrm>
+          <a:prstGeom prst="rect">
+            <a:avLst/>
+          </a:prstGeom>
+          <a:noFill/>
+        </p:spPr>
+        <p:txBody>
+          <a:bodyPr wrap="square" lIns="0" tIns="0" rIns="0" bIns="0">
+            <a:spAutoFit/>
+          </a:bodyPr>
+          <a:lstStyle/>
+          <a:p>
+            <a:pPr marL="0" indent="0" algn="l">
+              <a:lnSpc>
+                <a:spcPts val="1590"/>
+              </a:lnSpc>
+              <a:spcBef>
+                <a:spcPts val="0"/>
+              </a:spcBef>
+              <a:spcAft>
+                <a:spcPts val="0"/>
+              </a:spcAft>
+              <a:buNone/>
+            </a:pPr>
+            <a:r>
+              <a:rPr b="1" sz="1350">
                 <a:solidFill>
                   <a:srgbClr val="102A43"/>
                 </a:solidFill>
@@ -24220,34 +24957,34 @@
         </p:nvSpPr>
         <p:spPr>
           <a:xfrm>
-            <a:off x="914400" y="4457700"/>
-            <a:ext cx="4955133" cy="192938"/>
-          </a:xfrm>
-          <a:prstGeom prst="rect">
-            <a:avLst/>
-          </a:prstGeom>
-          <a:noFill/>
-        </p:spPr>
-        <p:txBody>
-          <a:bodyPr wrap="square" lIns="0" tIns="0" rIns="0" bIns="0">
-            <a:spAutoFit/>
-          </a:bodyPr>
-          <a:lstStyle/>
-          <a:p>
-            <a:pPr marL="0" indent="0" algn="l">
-              <a:lnSpc>
-                <a:spcPts val="1520"/>
-              </a:lnSpc>
-              <a:spcBef>
-                <a:spcPts val="0"/>
-              </a:spcBef>
-              <a:spcAft>
-                <a:spcPts val="0"/>
-              </a:spcAft>
-              <a:buNone/>
-            </a:pPr>
-            <a:r>
-              <a:rPr sz="1050">
+            <a:off x="914400" y="4095597"/>
+            <a:ext cx="4955133" cy="172821"/>
+          </a:xfrm>
+          <a:prstGeom prst="rect">
+            <a:avLst/>
+          </a:prstGeom>
+          <a:noFill/>
+        </p:spPr>
+        <p:txBody>
+          <a:bodyPr wrap="square" lIns="0" tIns="0" rIns="0" bIns="0">
+            <a:spAutoFit/>
+          </a:bodyPr>
+          <a:lstStyle/>
+          <a:p>
+            <a:pPr marL="0" indent="0" algn="l">
+              <a:lnSpc>
+                <a:spcPts val="1360"/>
+              </a:lnSpc>
+              <a:spcBef>
+                <a:spcPts val="0"/>
+              </a:spcBef>
+              <a:spcAft>
+                <a:spcPts val="0"/>
+              </a:spcAft>
+              <a:buNone/>
+            </a:pPr>
+            <a:r>
+              <a:rPr sz="980">
                 <a:solidFill>
                   <a:srgbClr val="53697C"/>
                 </a:solidFill>
@@ -24266,34 +25003,34 @@
         </p:nvSpPr>
         <p:spPr>
           <a:xfrm>
-            <a:off x="914400" y="5143500"/>
-            <a:ext cx="4955133" cy="178308"/>
-          </a:xfrm>
-          <a:prstGeom prst="rect">
-            <a:avLst/>
-          </a:prstGeom>
-          <a:noFill/>
-        </p:spPr>
-        <p:txBody>
-          <a:bodyPr wrap="square" lIns="0" tIns="0" rIns="0" bIns="0">
-            <a:spAutoFit/>
-          </a:bodyPr>
-          <a:lstStyle/>
-          <a:p>
-            <a:pPr marL="0" indent="0" algn="l">
-              <a:lnSpc>
-                <a:spcPts val="1410"/>
-              </a:lnSpc>
-              <a:spcBef>
-                <a:spcPts val="0"/>
-              </a:spcBef>
-              <a:spcAft>
-                <a:spcPts val="0"/>
-              </a:spcAft>
-              <a:buNone/>
-            </a:pPr>
-            <a:r>
-              <a:rPr b="1" sz="1050">
+            <a:off x="914400" y="4552797"/>
+            <a:ext cx="4955133" cy="152704"/>
+          </a:xfrm>
+          <a:prstGeom prst="rect">
+            <a:avLst/>
+          </a:prstGeom>
+          <a:noFill/>
+        </p:spPr>
+        <p:txBody>
+          <a:bodyPr wrap="square" lIns="0" tIns="0" rIns="0" bIns="0">
+            <a:spAutoFit/>
+          </a:bodyPr>
+          <a:lstStyle/>
+          <a:p>
+            <a:pPr marL="0" indent="0" algn="l">
+              <a:lnSpc>
+                <a:spcPts val="1210"/>
+              </a:lnSpc>
+              <a:spcBef>
+                <a:spcPts val="0"/>
+              </a:spcBef>
+              <a:spcAft>
+                <a:spcPts val="0"/>
+              </a:spcAft>
+              <a:buNone/>
+            </a:pPr>
+            <a:r>
+              <a:rPr b="1" sz="900">
                 <a:solidFill>
                   <a:srgbClr val="F26B4B"/>
                 </a:solidFill>
@@ -24313,11 +25050,11 @@
         <p:spPr>
           <a:xfrm>
             <a:off x="6210604" y="2229307"/>
-            <a:ext cx="5296204" cy="3504895"/>
+            <a:ext cx="5296204" cy="2704795"/>
           </a:xfrm>
           <a:prstGeom prst="roundRect">
             <a:avLst>
-              <a:gd name="adj" fmla="val 4890"/>
+              <a:gd name="adj" fmla="val 6340"/>
             </a:avLst>
           </a:prstGeom>
           <a:solidFill>
@@ -24360,8 +25097,8 @@
         </p:nvSpPr>
         <p:spPr>
           <a:xfrm>
-            <a:off x="6439204" y="2400300"/>
-            <a:ext cx="1699869" cy="160020"/>
+            <a:off x="6439204" y="2361895"/>
+            <a:ext cx="4955133" cy="160020"/>
           </a:xfrm>
           <a:prstGeom prst="rect">
             <a:avLst/>
@@ -24406,34 +25143,34 @@
         </p:nvSpPr>
         <p:spPr>
           <a:xfrm>
-            <a:off x="6439204" y="2704795"/>
-            <a:ext cx="4955133" cy="224942"/>
-          </a:xfrm>
-          <a:prstGeom prst="rect">
-            <a:avLst/>
-          </a:prstGeom>
-          <a:noFill/>
-        </p:spPr>
-        <p:txBody>
-          <a:bodyPr wrap="square" lIns="0" tIns="0" rIns="0" bIns="0">
-            <a:spAutoFit/>
-          </a:bodyPr>
-          <a:lstStyle/>
-          <a:p>
-            <a:pPr marL="0" indent="0" algn="l">
-              <a:lnSpc>
-                <a:spcPts val="1770"/>
-              </a:lnSpc>
-              <a:spcBef>
-                <a:spcPts val="0"/>
-              </a:spcBef>
-              <a:spcAft>
-                <a:spcPts val="0"/>
-              </a:spcAft>
-              <a:buNone/>
-            </a:pPr>
-            <a:r>
-              <a:rPr b="1" sz="1500">
+            <a:off x="6439204" y="2628900"/>
+            <a:ext cx="4955133" cy="202082"/>
+          </a:xfrm>
+          <a:prstGeom prst="rect">
+            <a:avLst/>
+          </a:prstGeom>
+          <a:noFill/>
+        </p:spPr>
+        <p:txBody>
+          <a:bodyPr wrap="square" lIns="0" tIns="0" rIns="0" bIns="0">
+            <a:spAutoFit/>
+          </a:bodyPr>
+          <a:lstStyle/>
+          <a:p>
+            <a:pPr marL="0" indent="0" algn="l">
+              <a:lnSpc>
+                <a:spcPts val="1590"/>
+              </a:lnSpc>
+              <a:spcBef>
+                <a:spcPts val="0"/>
+              </a:spcBef>
+              <a:spcAft>
+                <a:spcPts val="0"/>
+              </a:spcAft>
+              <a:buNone/>
+            </a:pPr>
+            <a:r>
+              <a:rPr b="1" sz="1350">
                 <a:solidFill>
                   <a:srgbClr val="102A43"/>
                 </a:solidFill>
@@ -24452,34 +25189,34 @@
         </p:nvSpPr>
         <p:spPr>
           <a:xfrm>
-            <a:off x="6439204" y="3010204"/>
-            <a:ext cx="4955133" cy="192938"/>
-          </a:xfrm>
-          <a:prstGeom prst="rect">
-            <a:avLst/>
-          </a:prstGeom>
-          <a:noFill/>
-        </p:spPr>
-        <p:txBody>
-          <a:bodyPr wrap="square" lIns="0" tIns="0" rIns="0" bIns="0">
-            <a:spAutoFit/>
-          </a:bodyPr>
-          <a:lstStyle/>
-          <a:p>
-            <a:pPr marL="0" indent="0" algn="l">
-              <a:lnSpc>
-                <a:spcPts val="1520"/>
-              </a:lnSpc>
-              <a:spcBef>
-                <a:spcPts val="0"/>
-              </a:spcBef>
-              <a:spcAft>
-                <a:spcPts val="0"/>
-              </a:spcAft>
-              <a:buNone/>
-            </a:pPr>
-            <a:r>
-              <a:rPr sz="1050">
+            <a:off x="6439204" y="2876702"/>
+            <a:ext cx="4955133" cy="172821"/>
+          </a:xfrm>
+          <a:prstGeom prst="rect">
+            <a:avLst/>
+          </a:prstGeom>
+          <a:noFill/>
+        </p:spPr>
+        <p:txBody>
+          <a:bodyPr wrap="square" lIns="0" tIns="0" rIns="0" bIns="0">
+            <a:spAutoFit/>
+          </a:bodyPr>
+          <a:lstStyle/>
+          <a:p>
+            <a:pPr marL="0" indent="0" algn="l">
+              <a:lnSpc>
+                <a:spcPts val="1360"/>
+              </a:lnSpc>
+              <a:spcBef>
+                <a:spcPts val="0"/>
+              </a:spcBef>
+              <a:spcAft>
+                <a:spcPts val="0"/>
+              </a:spcAft>
+              <a:buNone/>
+            </a:pPr>
+            <a:r>
+              <a:rPr sz="980">
                 <a:solidFill>
                   <a:srgbClr val="53697C"/>
                 </a:solidFill>
@@ -24498,34 +25235,34 @@
         </p:nvSpPr>
         <p:spPr>
           <a:xfrm>
-            <a:off x="6439204" y="3429000"/>
-            <a:ext cx="4955133" cy="224942"/>
-          </a:xfrm>
-          <a:prstGeom prst="rect">
-            <a:avLst/>
-          </a:prstGeom>
-          <a:noFill/>
-        </p:spPr>
-        <p:txBody>
-          <a:bodyPr wrap="square" lIns="0" tIns="0" rIns="0" bIns="0">
-            <a:spAutoFit/>
-          </a:bodyPr>
-          <a:lstStyle/>
-          <a:p>
-            <a:pPr marL="0" indent="0" algn="l">
-              <a:lnSpc>
-                <a:spcPts val="1770"/>
-              </a:lnSpc>
-              <a:spcBef>
-                <a:spcPts val="0"/>
-              </a:spcBef>
-              <a:spcAft>
-                <a:spcPts val="0"/>
-              </a:spcAft>
-              <a:buNone/>
-            </a:pPr>
-            <a:r>
-              <a:rPr b="1" sz="1500">
+            <a:off x="6439204" y="3238804"/>
+            <a:ext cx="4955133" cy="202082"/>
+          </a:xfrm>
+          <a:prstGeom prst="rect">
+            <a:avLst/>
+          </a:prstGeom>
+          <a:noFill/>
+        </p:spPr>
+        <p:txBody>
+          <a:bodyPr wrap="square" lIns="0" tIns="0" rIns="0" bIns="0">
+            <a:spAutoFit/>
+          </a:bodyPr>
+          <a:lstStyle/>
+          <a:p>
+            <a:pPr marL="0" indent="0" algn="l">
+              <a:lnSpc>
+                <a:spcPts val="1590"/>
+              </a:lnSpc>
+              <a:spcBef>
+                <a:spcPts val="0"/>
+              </a:spcBef>
+              <a:spcAft>
+                <a:spcPts val="0"/>
+              </a:spcAft>
+              <a:buNone/>
+            </a:pPr>
+            <a:r>
+              <a:rPr b="1" sz="1350">
                 <a:solidFill>
                   <a:srgbClr val="102A43"/>
                 </a:solidFill>
@@ -24544,34 +25281,34 @@
         </p:nvSpPr>
         <p:spPr>
           <a:xfrm>
-            <a:off x="6439204" y="3733495"/>
-            <a:ext cx="4955133" cy="192938"/>
-          </a:xfrm>
-          <a:prstGeom prst="rect">
-            <a:avLst/>
-          </a:prstGeom>
-          <a:noFill/>
-        </p:spPr>
-        <p:txBody>
-          <a:bodyPr wrap="square" lIns="0" tIns="0" rIns="0" bIns="0">
-            <a:spAutoFit/>
-          </a:bodyPr>
-          <a:lstStyle/>
-          <a:p>
-            <a:pPr marL="0" indent="0" algn="l">
-              <a:lnSpc>
-                <a:spcPts val="1520"/>
-              </a:lnSpc>
-              <a:spcBef>
-                <a:spcPts val="0"/>
-              </a:spcBef>
-              <a:spcAft>
-                <a:spcPts val="0"/>
-              </a:spcAft>
-              <a:buNone/>
-            </a:pPr>
-            <a:r>
-              <a:rPr sz="1050">
+            <a:off x="6439204" y="3485692"/>
+            <a:ext cx="4955133" cy="172821"/>
+          </a:xfrm>
+          <a:prstGeom prst="rect">
+            <a:avLst/>
+          </a:prstGeom>
+          <a:noFill/>
+        </p:spPr>
+        <p:txBody>
+          <a:bodyPr wrap="square" lIns="0" tIns="0" rIns="0" bIns="0">
+            <a:spAutoFit/>
+          </a:bodyPr>
+          <a:lstStyle/>
+          <a:p>
+            <a:pPr marL="0" indent="0" algn="l">
+              <a:lnSpc>
+                <a:spcPts val="1360"/>
+              </a:lnSpc>
+              <a:spcBef>
+                <a:spcPts val="0"/>
+              </a:spcBef>
+              <a:spcAft>
+                <a:spcPts val="0"/>
+              </a:spcAft>
+              <a:buNone/>
+            </a:pPr>
+            <a:r>
+              <a:rPr sz="980">
                 <a:solidFill>
                   <a:srgbClr val="53697C"/>
                 </a:solidFill>
@@ -24590,34 +25327,34 @@
         </p:nvSpPr>
         <p:spPr>
           <a:xfrm>
-            <a:off x="6439204" y="4153204"/>
-            <a:ext cx="4955133" cy="224942"/>
-          </a:xfrm>
-          <a:prstGeom prst="rect">
-            <a:avLst/>
-          </a:prstGeom>
-          <a:noFill/>
-        </p:spPr>
-        <p:txBody>
-          <a:bodyPr wrap="square" lIns="0" tIns="0" rIns="0" bIns="0">
-            <a:spAutoFit/>
-          </a:bodyPr>
-          <a:lstStyle/>
-          <a:p>
-            <a:pPr marL="0" indent="0" algn="l">
-              <a:lnSpc>
-                <a:spcPts val="1770"/>
-              </a:lnSpc>
-              <a:spcBef>
-                <a:spcPts val="0"/>
-              </a:spcBef>
-              <a:spcAft>
-                <a:spcPts val="0"/>
-              </a:spcAft>
-              <a:buNone/>
-            </a:pPr>
-            <a:r>
-              <a:rPr b="1" sz="1500">
+            <a:off x="6439204" y="3847795"/>
+            <a:ext cx="4955133" cy="202082"/>
+          </a:xfrm>
+          <a:prstGeom prst="rect">
+            <a:avLst/>
+          </a:prstGeom>
+          <a:noFill/>
+        </p:spPr>
+        <p:txBody>
+          <a:bodyPr wrap="square" lIns="0" tIns="0" rIns="0" bIns="0">
+            <a:spAutoFit/>
+          </a:bodyPr>
+          <a:lstStyle/>
+          <a:p>
+            <a:pPr marL="0" indent="0" algn="l">
+              <a:lnSpc>
+                <a:spcPts val="1590"/>
+              </a:lnSpc>
+              <a:spcBef>
+                <a:spcPts val="0"/>
+              </a:spcBef>
+              <a:spcAft>
+                <a:spcPts val="0"/>
+              </a:spcAft>
+              <a:buNone/>
+            </a:pPr>
+            <a:r>
+              <a:rPr b="1" sz="1350">
                 <a:solidFill>
                   <a:srgbClr val="102A43"/>
                 </a:solidFill>
@@ -24636,34 +25373,34 @@
         </p:nvSpPr>
         <p:spPr>
           <a:xfrm>
-            <a:off x="6439204" y="4457700"/>
-            <a:ext cx="4955133" cy="192938"/>
-          </a:xfrm>
-          <a:prstGeom prst="rect">
-            <a:avLst/>
-          </a:prstGeom>
-          <a:noFill/>
-        </p:spPr>
-        <p:txBody>
-          <a:bodyPr wrap="square" lIns="0" tIns="0" rIns="0" bIns="0">
-            <a:spAutoFit/>
-          </a:bodyPr>
-          <a:lstStyle/>
-          <a:p>
-            <a:pPr marL="0" indent="0" algn="l">
-              <a:lnSpc>
-                <a:spcPts val="1520"/>
-              </a:lnSpc>
-              <a:spcBef>
-                <a:spcPts val="0"/>
-              </a:spcBef>
-              <a:spcAft>
-                <a:spcPts val="0"/>
-              </a:spcAft>
-              <a:buNone/>
-            </a:pPr>
-            <a:r>
-              <a:rPr sz="1050">
+            <a:off x="6439204" y="4095597"/>
+            <a:ext cx="4955133" cy="172821"/>
+          </a:xfrm>
+          <a:prstGeom prst="rect">
+            <a:avLst/>
+          </a:prstGeom>
+          <a:noFill/>
+        </p:spPr>
+        <p:txBody>
+          <a:bodyPr wrap="square" lIns="0" tIns="0" rIns="0" bIns="0">
+            <a:spAutoFit/>
+          </a:bodyPr>
+          <a:lstStyle/>
+          <a:p>
+            <a:pPr marL="0" indent="0" algn="l">
+              <a:lnSpc>
+                <a:spcPts val="1360"/>
+              </a:lnSpc>
+              <a:spcBef>
+                <a:spcPts val="0"/>
+              </a:spcBef>
+              <a:spcAft>
+                <a:spcPts val="0"/>
+              </a:spcAft>
+              <a:buNone/>
+            </a:pPr>
+            <a:r>
+              <a:rPr sz="980">
                 <a:solidFill>
                   <a:srgbClr val="53697C"/>
                 </a:solidFill>
@@ -24682,23 +25419,117 @@
         </p:nvSpPr>
         <p:spPr>
           <a:xfrm>
-            <a:off x="6439204" y="5143500"/>
-            <a:ext cx="4955133" cy="178308"/>
-          </a:xfrm>
-          <a:prstGeom prst="rect">
-            <a:avLst/>
-          </a:prstGeom>
-          <a:noFill/>
-        </p:spPr>
-        <p:txBody>
-          <a:bodyPr wrap="square" lIns="0" tIns="0" rIns="0" bIns="0">
-            <a:spAutoFit/>
-          </a:bodyPr>
-          <a:lstStyle/>
-          <a:p>
-            <a:pPr marL="0" indent="0" algn="l">
-              <a:lnSpc>
-                <a:spcPts val="1410"/>
+            <a:off x="6439204" y="4552797"/>
+            <a:ext cx="4955133" cy="152704"/>
+          </a:xfrm>
+          <a:prstGeom prst="rect">
+            <a:avLst/>
+          </a:prstGeom>
+          <a:noFill/>
+        </p:spPr>
+        <p:txBody>
+          <a:bodyPr wrap="square" lIns="0" tIns="0" rIns="0" bIns="0">
+            <a:spAutoFit/>
+          </a:bodyPr>
+          <a:lstStyle/>
+          <a:p>
+            <a:pPr marL="0" indent="0" algn="l">
+              <a:lnSpc>
+                <a:spcPts val="1210"/>
+              </a:lnSpc>
+              <a:spcBef>
+                <a:spcPts val="0"/>
+              </a:spcBef>
+              <a:spcAft>
+                <a:spcPts val="0"/>
+              </a:spcAft>
+              <a:buNone/>
+            </a:pPr>
+            <a:r>
+              <a:rPr b="1" sz="900">
+                <a:solidFill>
+                  <a:srgbClr val="D6A43B"/>
+                </a:solidFill>
+                <a:latin typeface="Noto Sans CJK SC"/>
+              </a:rPr>
+              <a:t>诚实拒绝 / 保留人工也是合法结论。</a:t>
+            </a:r>
+          </a:p>
+        </p:txBody>
+      </p:sp>
+      <p:sp>
+        <p:nvSpPr>
+          <p:cNvPr id="25" name="h2p-6-box-24"/>
+          <p:cNvSpPr/>
+          <p:nvPr/>
+        </p:nvSpPr>
+        <p:spPr>
+          <a:xfrm>
+            <a:off x="685800" y="5048402"/>
+            <a:ext cx="10820095" cy="933602"/>
+          </a:xfrm>
+          <a:prstGeom prst="roundRect">
+            <a:avLst>
+              <a:gd name="adj" fmla="val 18370"/>
+            </a:avLst>
+          </a:prstGeom>
+          <a:solidFill>
+            <a:srgbClr val="FFFFFF"/>
+          </a:solidFill>
+          <a:ln w="19050">
+            <a:solidFill>
+              <a:srgbClr val="D6DDD9"/>
+            </a:solidFill>
+          </a:ln>
+          <a:effectLst/>
+        </p:spPr>
+        <p:style>
+          <a:lnRef idx="1">
+            <a:schemeClr val="accent1"/>
+          </a:lnRef>
+          <a:fillRef idx="3">
+            <a:schemeClr val="accent1"/>
+          </a:fillRef>
+          <a:effectRef idx="0">
+            <a:schemeClr val="accent1"/>
+          </a:effectRef>
+          <a:fontRef idx="minor">
+            <a:schemeClr val="lt1"/>
+          </a:fontRef>
+        </p:style>
+        <p:txBody>
+          <a:bodyPr rtlCol="0" anchor="ctr"/>
+          <a:lstStyle/>
+          <a:p>
+            <a:pPr algn="ctr"/>
+          </a:p>
+        </p:txBody>
+      </p:sp>
+      <p:sp>
+        <p:nvSpPr>
+          <p:cNvPr id="26" name="h2p-6-text-25"/>
+          <p:cNvSpPr txBox="1"/>
+          <p:nvPr/>
+        </p:nvSpPr>
+        <p:spPr>
+          <a:xfrm>
+            <a:off x="914400" y="5162702"/>
+            <a:ext cx="5052060" cy="160020"/>
+          </a:xfrm>
+          <a:prstGeom prst="rect">
+            <a:avLst/>
+          </a:prstGeom>
+          <a:noFill/>
+        </p:spPr>
+        <p:txBody>
+          <a:bodyPr wrap="square" lIns="0" tIns="0" rIns="0" bIns="0">
+            <a:spAutoFit/>
+          </a:bodyPr>
+          <a:lstStyle/>
+          <a:p>
+            <a:pPr marL="0" indent="0" algn="l">
+              <a:lnSpc>
+                <a:spcPts val="1260"/>
               </a:lnSpc>
               <a:spcBef>
                 <a:spcPts val="0"/>
@@ -24711,64 +25542,440 @@
             <a:r>
               <a:rPr b="1" sz="1050">
                 <a:solidFill>
-                  <a:srgbClr val="D6A43B"/>
+                  <a:srgbClr val="53697C"/>
+                </a:solidFill>
+                <a:latin typeface="Noto Sans Mono CJK SC"/>
+              </a:rPr>
+              <a:t>候选搜索顺序 · 设计契约（非运行结果）</a:t>
+            </a:r>
+          </a:p>
+        </p:txBody>
+      </p:sp>
+      <p:sp>
+        <p:nvSpPr>
+          <p:cNvPr id="27" name="h2p-6-box-26"/>
+          <p:cNvSpPr/>
+          <p:nvPr/>
+        </p:nvSpPr>
+        <p:spPr>
+          <a:xfrm>
+            <a:off x="914400" y="5429707"/>
+            <a:ext cx="2400300" cy="342900"/>
+          </a:xfrm>
+          <a:prstGeom prst="roundRect">
+            <a:avLst>
+              <a:gd name="adj" fmla="val 22220"/>
+            </a:avLst>
+          </a:prstGeom>
+          <a:solidFill>
+            <a:srgbClr val="DFEAF2"/>
+          </a:solidFill>
+          <a:ln w="10160">
+            <a:solidFill>
+              <a:srgbClr val="426B86"/>
+            </a:solidFill>
+          </a:ln>
+          <a:effectLst/>
+        </p:spPr>
+        <p:style>
+          <a:lnRef idx="1">
+            <a:schemeClr val="accent1"/>
+          </a:lnRef>
+          <a:fillRef idx="3">
+            <a:schemeClr val="accent1"/>
+          </a:fillRef>
+          <a:effectRef idx="0">
+            <a:schemeClr val="accent1"/>
+          </a:effectRef>
+          <a:fontRef idx="minor">
+            <a:schemeClr val="lt1"/>
+          </a:fontRef>
+        </p:style>
+        <p:txBody>
+          <a:bodyPr rtlCol="0" anchor="ctr"/>
+          <a:lstStyle/>
+          <a:p>
+            <a:pPr algn="ctr"/>
+          </a:p>
+        </p:txBody>
+      </p:sp>
+      <p:sp>
+        <p:nvSpPr>
+          <p:cNvPr id="28" name="h2p-6-text-27"/>
+          <p:cNvSpPr txBox="1"/>
+          <p:nvPr/>
+        </p:nvSpPr>
+        <p:spPr>
+          <a:xfrm>
+            <a:off x="1000353" y="5505602"/>
+            <a:ext cx="2273198" cy="148132"/>
+          </a:xfrm>
+          <a:prstGeom prst="rect">
+            <a:avLst/>
+          </a:prstGeom>
+          <a:noFill/>
+        </p:spPr>
+        <p:txBody>
+          <a:bodyPr wrap="square" lIns="0" tIns="0" rIns="0" bIns="0">
+            <a:spAutoFit/>
+          </a:bodyPr>
+          <a:lstStyle/>
+          <a:p>
+            <a:pPr marL="0" indent="0" algn="l">
+              <a:lnSpc>
+                <a:spcPts val="1170"/>
+              </a:lnSpc>
+              <a:spcBef>
+                <a:spcPts val="0"/>
+              </a:spcBef>
+              <a:spcAft>
+                <a:spcPts val="0"/>
+              </a:spcAft>
+              <a:buNone/>
+            </a:pPr>
+            <a:r>
+              <a:rPr b="1" sz="980">
+                <a:solidFill>
+                  <a:srgbClr val="426B86"/>
+                </a:solidFill>
+                <a:latin typeface="Noto Sans Mono CJK SC"/>
+              </a:rPr>
+              <a:t>C0 · Agentless · 待真实试验</a:t>
+            </a:r>
+          </a:p>
+        </p:txBody>
+      </p:sp>
+      <p:sp>
+        <p:nvSpPr>
+          <p:cNvPr id="29" name="h2p-6-box-28"/>
+          <p:cNvSpPr/>
+          <p:nvPr/>
+        </p:nvSpPr>
+        <p:spPr>
+          <a:xfrm>
+            <a:off x="3429000" y="5429707"/>
+            <a:ext cx="2400300" cy="342900"/>
+          </a:xfrm>
+          <a:prstGeom prst="roundRect">
+            <a:avLst>
+              <a:gd name="adj" fmla="val 22220"/>
+            </a:avLst>
+          </a:prstGeom>
+          <a:solidFill>
+            <a:srgbClr val="DCEEEA"/>
+          </a:solidFill>
+          <a:ln w="10160">
+            <a:solidFill>
+              <a:srgbClr val="1A8D85"/>
+            </a:solidFill>
+          </a:ln>
+          <a:effectLst/>
+        </p:spPr>
+        <p:style>
+          <a:lnRef idx="1">
+            <a:schemeClr val="accent1"/>
+          </a:lnRef>
+          <a:fillRef idx="3">
+            <a:schemeClr val="accent1"/>
+          </a:fillRef>
+          <a:effectRef idx="0">
+            <a:schemeClr val="accent1"/>
+          </a:effectRef>
+          <a:fontRef idx="minor">
+            <a:schemeClr val="lt1"/>
+          </a:fontRef>
+        </p:style>
+        <p:txBody>
+          <a:bodyPr rtlCol="0" anchor="ctr"/>
+          <a:lstStyle/>
+          <a:p>
+            <a:pPr algn="ctr"/>
+          </a:p>
+        </p:txBody>
+      </p:sp>
+      <p:sp>
+        <p:nvSpPr>
+          <p:cNvPr id="30" name="h2p-6-text-29"/>
+          <p:cNvSpPr txBox="1"/>
+          <p:nvPr/>
+        </p:nvSpPr>
+        <p:spPr>
+          <a:xfrm>
+            <a:off x="3514953" y="5505602"/>
+            <a:ext cx="2273198" cy="148132"/>
+          </a:xfrm>
+          <a:prstGeom prst="rect">
+            <a:avLst/>
+          </a:prstGeom>
+          <a:noFill/>
+        </p:spPr>
+        <p:txBody>
+          <a:bodyPr wrap="square" lIns="0" tIns="0" rIns="0" bIns="0">
+            <a:spAutoFit/>
+          </a:bodyPr>
+          <a:lstStyle/>
+          <a:p>
+            <a:pPr marL="0" indent="0" algn="l">
+              <a:lnSpc>
+                <a:spcPts val="1170"/>
+              </a:lnSpc>
+              <a:spcBef>
+                <a:spcPts val="0"/>
+              </a:spcBef>
+              <a:spcAft>
+                <a:spcPts val="0"/>
+              </a:spcAft>
+              <a:buNone/>
+            </a:pPr>
+            <a:r>
+              <a:rPr b="1" sz="980">
+                <a:solidFill>
+                  <a:srgbClr val="1A8D85"/>
+                </a:solidFill>
+                <a:latin typeface="Noto Sans Mono CJK SC"/>
+              </a:rPr>
+              <a:t>C1 · 单 Agent · 待真实试验</a:t>
+            </a:r>
+          </a:p>
+        </p:txBody>
+      </p:sp>
+      <p:sp>
+        <p:nvSpPr>
+          <p:cNvPr id="31" name="h2p-6-box-30"/>
+          <p:cNvSpPr/>
+          <p:nvPr/>
+        </p:nvSpPr>
+        <p:spPr>
+          <a:xfrm>
+            <a:off x="5943600" y="5429707"/>
+            <a:ext cx="2400300" cy="342900"/>
+          </a:xfrm>
+          <a:prstGeom prst="roundRect">
+            <a:avLst>
+              <a:gd name="adj" fmla="val 22220"/>
+            </a:avLst>
+          </a:prstGeom>
+          <a:solidFill>
+            <a:srgbClr val="F8DDD4"/>
+          </a:solidFill>
+          <a:ln w="10160">
+            <a:solidFill>
+              <a:srgbClr val="F26B4B"/>
+            </a:solidFill>
+          </a:ln>
+          <a:effectLst/>
+        </p:spPr>
+        <p:style>
+          <a:lnRef idx="1">
+            <a:schemeClr val="accent1"/>
+          </a:lnRef>
+          <a:fillRef idx="3">
+            <a:schemeClr val="accent1"/>
+          </a:fillRef>
+          <a:effectRef idx="0">
+            <a:schemeClr val="accent1"/>
+          </a:effectRef>
+          <a:fontRef idx="minor">
+            <a:schemeClr val="lt1"/>
+          </a:fontRef>
+        </p:style>
+        <p:txBody>
+          <a:bodyPr rtlCol="0" anchor="ctr"/>
+          <a:lstStyle/>
+          <a:p>
+            <a:pPr algn="ctr"/>
+          </a:p>
+        </p:txBody>
+      </p:sp>
+      <p:sp>
+        <p:nvSpPr>
+          <p:cNvPr id="32" name="h2p-6-text-31"/>
+          <p:cNvSpPr txBox="1"/>
+          <p:nvPr/>
+        </p:nvSpPr>
+        <p:spPr>
+          <a:xfrm>
+            <a:off x="6029553" y="5505602"/>
+            <a:ext cx="2273198" cy="148132"/>
+          </a:xfrm>
+          <a:prstGeom prst="rect">
+            <a:avLst/>
+          </a:prstGeom>
+          <a:noFill/>
+        </p:spPr>
+        <p:txBody>
+          <a:bodyPr wrap="square" lIns="0" tIns="0" rIns="0" bIns="0">
+            <a:spAutoFit/>
+          </a:bodyPr>
+          <a:lstStyle/>
+          <a:p>
+            <a:pPr marL="0" indent="0" algn="l">
+              <a:lnSpc>
+                <a:spcPts val="1170"/>
+              </a:lnSpc>
+              <a:spcBef>
+                <a:spcPts val="0"/>
+              </a:spcBef>
+              <a:spcAft>
+                <a:spcPts val="0"/>
+              </a:spcAft>
+              <a:buNone/>
+            </a:pPr>
+            <a:r>
+              <a:rPr b="1" sz="980">
+                <a:solidFill>
+                  <a:srgbClr val="C64C32"/>
+                </a:solidFill>
+                <a:latin typeface="Noto Sans Mono CJK SC"/>
+              </a:rPr>
+              <a:t>C2 · 多 Agent · 待真实试验</a:t>
+            </a:r>
+          </a:p>
+        </p:txBody>
+      </p:sp>
+      <p:sp>
+        <p:nvSpPr>
+          <p:cNvPr id="33" name="h2p-6-box-32"/>
+          <p:cNvSpPr/>
+          <p:nvPr/>
+        </p:nvSpPr>
+        <p:spPr>
+          <a:xfrm>
+            <a:off x="8458200" y="5429707"/>
+            <a:ext cx="2400300" cy="342900"/>
+          </a:xfrm>
+          <a:prstGeom prst="roundRect">
+            <a:avLst>
+              <a:gd name="adj" fmla="val 22220"/>
+            </a:avLst>
+          </a:prstGeom>
+          <a:solidFill>
+            <a:srgbClr val="F3E5B8"/>
+          </a:solidFill>
+          <a:ln w="10160">
+            <a:solidFill>
+              <a:srgbClr val="D6A43B"/>
+            </a:solidFill>
+          </a:ln>
+          <a:effectLst/>
+        </p:spPr>
+        <p:style>
+          <a:lnRef idx="1">
+            <a:schemeClr val="accent1"/>
+          </a:lnRef>
+          <a:fillRef idx="3">
+            <a:schemeClr val="accent1"/>
+          </a:fillRef>
+          <a:effectRef idx="0">
+            <a:schemeClr val="accent1"/>
+          </a:effectRef>
+          <a:fontRef idx="minor">
+            <a:schemeClr val="lt1"/>
+          </a:fontRef>
+        </p:style>
+        <p:txBody>
+          <a:bodyPr rtlCol="0" anchor="ctr"/>
+          <a:lstStyle/>
+          <a:p>
+            <a:pPr algn="ctr"/>
+          </a:p>
+        </p:txBody>
+      </p:sp>
+      <p:sp>
+        <p:nvSpPr>
+          <p:cNvPr id="34" name="h2p-6-text-33"/>
+          <p:cNvSpPr txBox="1"/>
+          <p:nvPr/>
+        </p:nvSpPr>
+        <p:spPr>
+          <a:xfrm>
+            <a:off x="8544153" y="5505602"/>
+            <a:ext cx="2273198" cy="148132"/>
+          </a:xfrm>
+          <a:prstGeom prst="rect">
+            <a:avLst/>
+          </a:prstGeom>
+          <a:noFill/>
+        </p:spPr>
+        <p:txBody>
+          <a:bodyPr wrap="square" lIns="0" tIns="0" rIns="0" bIns="0">
+            <a:spAutoFit/>
+          </a:bodyPr>
+          <a:lstStyle/>
+          <a:p>
+            <a:pPr marL="0" indent="0" algn="l">
+              <a:lnSpc>
+                <a:spcPts val="1170"/>
+              </a:lnSpc>
+              <a:spcBef>
+                <a:spcPts val="0"/>
+              </a:spcBef>
+              <a:spcAft>
+                <a:spcPts val="0"/>
+              </a:spcAft>
+              <a:buNone/>
+            </a:pPr>
+            <a:r>
+              <a:rPr b="1" sz="980">
+                <a:solidFill>
+                  <a:srgbClr val="A5781C"/>
+                </a:solidFill>
+                <a:latin typeface="Noto Sans Mono CJK SC"/>
+              </a:rPr>
+              <a:t>C3 · Human 混合 · 待真实试验</a:t>
+            </a:r>
+          </a:p>
+        </p:txBody>
+      </p:sp>
+      <p:sp>
+        <p:nvSpPr>
+          <p:cNvPr id="35" name="h2p-6-text-34"/>
+          <p:cNvSpPr txBox="1"/>
+          <p:nvPr/>
+        </p:nvSpPr>
+        <p:spPr>
+          <a:xfrm>
+            <a:off x="577900" y="6096304"/>
+            <a:ext cx="11036808" cy="216712"/>
+          </a:xfrm>
+          <a:prstGeom prst="rect">
+            <a:avLst/>
+          </a:prstGeom>
+          <a:noFill/>
+        </p:spPr>
+        <p:txBody>
+          <a:bodyPr wrap="square" lIns="0" tIns="0" rIns="0" bIns="0">
+            <a:spAutoFit/>
+          </a:bodyPr>
+          <a:lstStyle/>
+          <a:p>
+            <a:pPr marL="0" indent="0" algn="ctr">
+              <a:lnSpc>
+                <a:spcPts val="1700"/>
+              </a:lnSpc>
+              <a:spcBef>
+                <a:spcPts val="0"/>
+              </a:spcBef>
+              <a:spcAft>
+                <a:spcPts val="0"/>
+              </a:spcAft>
+              <a:buNone/>
+            </a:pPr>
+            <a:r>
+              <a:rPr b="1" sz="1200">
+                <a:solidFill>
+                  <a:srgbClr val="102A43"/>
                 </a:solidFill>
                 <a:latin typeface="Noto Sans CJK SC"/>
               </a:rPr>
-              <a:t>诚实拒绝 / 保留人工也是合法结论。</a:t>
-            </a:r>
-          </a:p>
-        </p:txBody>
-      </p:sp>
-      <p:sp>
-        <p:nvSpPr>
-          <p:cNvPr id="25" name="h2p-6-text-24"/>
-          <p:cNvSpPr txBox="1"/>
-          <p:nvPr/>
-        </p:nvSpPr>
-        <p:spPr>
-          <a:xfrm>
-            <a:off x="577900" y="5924397"/>
-            <a:ext cx="11036808" cy="243230"/>
-          </a:xfrm>
-          <a:prstGeom prst="rect">
-            <a:avLst/>
-          </a:prstGeom>
-          <a:noFill/>
-        </p:spPr>
-        <p:txBody>
-          <a:bodyPr wrap="square" lIns="0" tIns="0" rIns="0" bIns="0">
-            <a:spAutoFit/>
-          </a:bodyPr>
-          <a:lstStyle/>
-          <a:p>
-            <a:pPr marL="0" indent="0" algn="ctr">
-              <a:lnSpc>
-                <a:spcPts val="1920"/>
-              </a:lnSpc>
-              <a:spcBef>
-                <a:spcPts val="0"/>
-              </a:spcBef>
-              <a:spcAft>
-                <a:spcPts val="0"/>
-              </a:spcAft>
-              <a:buNone/>
-            </a:pPr>
-            <a:r>
-              <a:rPr b="1" sz="1350">
-                <a:solidFill>
-                  <a:srgbClr val="102A43"/>
-                </a:solidFill>
-                <a:latin typeface="Noto Sans CJK SC"/>
-              </a:rPr>
-              <a:t>规则写在候选生成之前；当前候选对照仍待真实运行，本轮结论 requires_runtime_trial。</a:t>
-            </a:r>
-          </a:p>
-        </p:txBody>
-      </p:sp>
-      <p:sp>
-        <p:nvSpPr>
-          <p:cNvPr id="26" name="h2p-6-text-25"/>
+              <a:t>规则写在候选生成之前；当前候选对照仍待真实运行，本轮结论 requires_runtime_trial（需进入真实受控试验）。</a:t>
+            </a:r>
+          </a:p>
+        </p:txBody>
+      </p:sp>
+      <p:sp>
+        <p:nvSpPr>
+          <p:cNvPr id="36" name="h2p-6-text-35"/>
           <p:cNvSpPr txBox="1"/>
           <p:nvPr/>
         </p:nvSpPr>
@@ -24814,7 +26021,7 @@
       </p:sp>
       <p:sp>
         <p:nvSpPr>
-          <p:cNvPr id="27" name="h2p-6-text-26"/>
+          <p:cNvPr id="37" name="h2p-6-text-36"/>
           <p:cNvSpPr txBox="1"/>
           <p:nvPr/>
         </p:nvSpPr>

</xml_diff>